<commit_message>
W03 SAT presentation deck: the demo rule with its two-minute recovery and a rekeyed S12, the Week 1 revenue-per-member example on S5, and the approved mini project rubric on S19; pptx rebuilt
</commit_message>
<xml_diff>
--- a/content/W03/SAT/slides/C2_W03_SAT_presentation_format_STUDENT.pptx
+++ b/content/W03/SAT/slides/C2_W03_SAT_presentation_format_STUDENT.pptx
@@ -29,6 +29,7 @@
     <p:sldId id="277" r:id="rId29"/>
     <p:sldId id="278" r:id="rId30"/>
     <p:sldId id="279" r:id="rId31"/>
+    <p:sldId id="280" r:id="rId32"/>
   </p:sldIdLst>
   <p:sldSz cx="12191695" cy="6858000" type="screen4x3"/>
   <p:notesSz cx="6858000" cy="9144000"/>
@@ -1055,12 +1056,27 @@
           <a:lstStyle/>
           <a:p>
             <a:r>
-              <a:t>A demo that fails and is explained honestly in one sentence is better evidence of understanding</a:t>
-            </a:r>
-          </a:p>
-          <a:p>
-            <a:r>
-              <a:t>than a demo that is rerun until it works. There is no second run.</a:t>
+              <a:t>The rule, word for word: a group's demo runs once, cold, on its raw files. If it fails, the group</a:t>
+            </a:r>
+          </a:p>
+          <a:p>
+            <a:r>
+              <a:t>has two minutes to recover it live, as it would in front of a client. If it still fails, the group</a:t>
+            </a:r>
+          </a:p>
+          <a:p>
+            <a:r>
+              <a:t>presents from its executed notebook, and the panel scores the live demo in presentation and defence</a:t>
+            </a:r>
+          </a:p>
+          <a:p>
+            <a:r>
+              <a:t>as not run cold. The other 34 marks of the mini project are scored from the executed run, so a</a:t>
+            </a:r>
+          </a:p>
+          <a:p>
+            <a:r>
+              <a:t>failed demo costs its own marks and never the analysis.</a:t>
             </a:r>
           </a:p>
         </p:txBody>
@@ -1130,7 +1146,7 @@
           <a:lstStyle/>
           <a:p>
             <a:r>
-              <a:t>Thirty seconds. Most rooms get c; d is the one worth discussing.</a:t>
+              <a:t>Thirty seconds. Most rooms split between c and d; the two-minute limit is what separates them.</a:t>
             </a:r>
           </a:p>
         </p:txBody>
@@ -1200,12 +1216,17 @@
           <a:lstStyle/>
           <a:p>
             <a:r>
-              <a:t>The answer is c. On d: a group whose demo breaks names the cause and moves on; the panel can ask</a:t>
-            </a:r>
-          </a:p>
-          <a:p>
-            <a:r>
-              <a:t>about the fix in questions.</a:t>
+              <a:t>The answer is d. If the demo still fails after two minutes, the group presents from its executed</a:t>
+            </a:r>
+          </a:p>
+          <a:p>
+            <a:r>
+              <a:t>notebook and the panel scores the live demo in presentation and defence as not run cold; the other</a:t>
+            </a:r>
+          </a:p>
+          <a:p>
+            <a:r>
+              <a:t>34 marks are scored from the executed run, so a failed demo costs its own marks and never the analysis.</a:t>
             </a:r>
           </a:p>
         </p:txBody>
@@ -1741,6 +1762,81 @@
           <a:p>
             <a:r>
               <a:t>same for every group.</a:t>
+            </a:r>
+          </a:p>
+        </p:txBody>
+      </p:sp>
+      <p:sp>
+        <p:nvSpPr>
+          <p:cNvPr id="4" name="Slide Number Placeholder 3"/>
+          <p:cNvSpPr>
+            <a:spLocks noGrp="1"/>
+          </p:cNvSpPr>
+          <p:nvPr>
+            <p:ph type="sldNum" idx="5" sz="quarter"/>
+          </p:nvPr>
+        </p:nvSpPr>
+        <p:spPr/>
+      </p:sp>
+    </p:spTree>
+  </p:cSld>
+  <p:clrMapOvr>
+    <a:masterClrMapping/>
+  </p:clrMapOvr>
+</p:notes>
+</file>
+
+<file path=ppt/notesSlides/notesSlide25.xml><?xml version="1.0" encoding="utf-8"?>
+<p:notes xmlns:a="http://schemas.openxmlformats.org/drawingml/2006/main" xmlns:p="http://schemas.openxmlformats.org/presentationml/2006/main" xmlns:r="http://schemas.openxmlformats.org/officeDocument/2006/relationships">
+  <p:cSld>
+    <p:spTree>
+      <p:nvGrpSpPr>
+        <p:cNvPr id="1" name=""/>
+        <p:cNvGrpSpPr/>
+        <p:nvPr/>
+      </p:nvGrpSpPr>
+      <p:grpSpPr>
+        <a:xfrm>
+          <a:off x="0" y="0"/>
+          <a:ext cx="0" cy="0"/>
+          <a:chOff x="0" y="0"/>
+          <a:chExt cx="0" cy="0"/>
+        </a:xfrm>
+      </p:grpSpPr>
+      <p:sp>
+        <p:nvSpPr>
+          <p:cNvPr id="2" name="Slide Image Placeholder 1"/>
+          <p:cNvSpPr>
+            <a:spLocks noGrp="1"/>
+          </p:cNvSpPr>
+          <p:nvPr>
+            <p:ph type="sldImg" idx="2"/>
+          </p:nvPr>
+        </p:nvSpPr>
+        <p:spPr/>
+      </p:sp>
+      <p:sp>
+        <p:nvSpPr>
+          <p:cNvPr id="3" name="Notes Placeholder 2"/>
+          <p:cNvSpPr>
+            <a:spLocks noGrp="1"/>
+          </p:cNvSpPr>
+          <p:nvPr>
+            <p:ph type="body" idx="3" sz="quarter"/>
+          </p:nvPr>
+        </p:nvSpPr>
+        <p:spPr/>
+        <p:txBody>
+          <a:bodyPr/>
+          <a:lstStyle/>
+          <a:p>
+            <a:r>
+              <a:t>Point groups to the last row: the live demo sits inside presentation and defence, so a demo that</a:t>
+            </a:r>
+          </a:p>
+          <a:p>
+            <a:r>
+              <a:t>fails after its two minutes costs those marks and leaves the other 34 to the executed run.</a:t>
             </a:r>
           </a:p>
         </p:txBody>
@@ -6018,7 +6114,7 @@
                 </a:solidFill>
                 <a:latin typeface="Calibri"/>
               </a:rPr>
-              <a:t>1 / 24</a:t>
+              <a:t>1 / 25</a:t>
             </a:r>
           </a:p>
         </p:txBody>
@@ -6604,7 +6700,7 @@
                 </a:solidFill>
                 <a:latin typeface="Calibri"/>
               </a:rPr>
-              <a:t>Week 3, Build 1: the presentation</a:t>
+              <a:t>Your answer, in front of the panel</a:t>
             </a:r>
           </a:p>
         </p:txBody>
@@ -6639,7 +6735,7 @@
                 </a:solidFill>
                 <a:latin typeface="Calibri"/>
               </a:rPr>
-              <a:t>10 / 24</a:t>
+              <a:t>10 / 25</a:t>
             </a:r>
           </a:p>
         </p:txBody>
@@ -7703,7 +7799,7 @@
                 </a:solidFill>
                 <a:latin typeface="Calibri"/>
               </a:rPr>
-              <a:t>S7  ·  11 / 24</a:t>
+              <a:t>S7  ·  11 / 25</a:t>
             </a:r>
           </a:p>
         </p:txBody>
@@ -8842,7 +8938,7 @@
                 </a:solidFill>
                 <a:latin typeface="Calibri"/>
               </a:rPr>
-              <a:t>S8  ·  12 / 24</a:t>
+              <a:t>S8  ·  12 / 25</a:t>
             </a:r>
           </a:p>
         </p:txBody>
@@ -9793,7 +9889,7 @@
                 </a:solidFill>
                 <a:latin typeface="Calibri"/>
               </a:rPr>
-              <a:t>S9  ·  13 / 24</a:t>
+              <a:t>S9  ·  13 / 25</a:t>
             </a:r>
           </a:p>
         </p:txBody>
@@ -10811,7 +10907,7 @@
                 </a:solidFill>
                 <a:latin typeface="Calibri"/>
               </a:rPr>
-              <a:t>S10  ·  14 / 24</a:t>
+              <a:t>S10  ·  14 / 25</a:t>
             </a:r>
           </a:p>
         </p:txBody>
@@ -11087,7 +11183,7 @@
                 </a:solidFill>
                 <a:latin typeface="Calibri"/>
               </a:rPr>
-              <a:t>Cold, from the raw files, in one run: the number on your one-slide answer, reproduced in front of the panel.</a:t>
+              <a:t>Cold, from the raw files, in one run with two minutes to recover: the number on your one-slide answer, reproduced in front of the panel.</a:t>
             </a:r>
           </a:p>
         </p:txBody>
@@ -11397,7 +11493,7 @@
                 </a:solidFill>
                 <a:latin typeface="Calibri"/>
               </a:rPr>
-              <a:t>Week 3, Build 1: the presentation</a:t>
+              <a:t>Your answer, in front of the panel</a:t>
             </a:r>
           </a:p>
         </p:txBody>
@@ -11432,7 +11528,7 @@
                 </a:solidFill>
                 <a:latin typeface="Calibri"/>
               </a:rPr>
-              <a:t>15 / 24</a:t>
+              <a:t>15 / 25</a:t>
             </a:r>
           </a:p>
         </p:txBody>
@@ -12339,7 +12435,7 @@
         <p:spPr>
           <a:xfrm>
             <a:off x="4380890" y="3029204"/>
-            <a:ext cx="1239469" cy="1126236"/>
+            <a:ext cx="1239469" cy="1307846"/>
           </a:xfrm>
           <a:prstGeom prst="rect">
             <a:avLst/>
@@ -12360,7 +12456,7 @@
                 </a:solidFill>
                 <a:latin typeface="Calibri"/>
               </a:rPr>
-              <a:t>One press, top to bottom. If it breaks, say in one sentence what broke and why, then go to questions.</a:t>
+              <a:t>One press, top to bottom. If it fails, you have two minutes to recover it live, as you would with a client.</a:t>
             </a:r>
           </a:p>
         </p:txBody>
@@ -12951,7 +13047,7 @@
                 </a:solidFill>
                 <a:latin typeface="Calibri"/>
               </a:rPr>
-              <a:t>S11  ·  16 / 24</a:t>
+              <a:t>S11  ·  16 / 25</a:t>
             </a:r>
           </a:p>
         </p:txBody>
@@ -13192,7 +13288,7 @@
                 </a:solidFill>
                 <a:latin typeface="Calibri"/>
               </a:rPr>
-              <a:t>Four groups describe their demo plan.</a:t>
+              <a:t>Four groups say what they will do if a cell fails on the cold run.</a:t>
             </a:r>
           </a:p>
         </p:txBody>
@@ -13329,7 +13425,7 @@
                 </a:solidFill>
                 <a:latin typeface="Calibri"/>
               </a:rPr>
-              <a:t>Which plan meets all three rules? Answer as a letter.</a:t>
+              <a:t>Which plan meets the demo rules? Answer as a letter.</a:t>
             </a:r>
           </a:p>
         </p:txBody>
@@ -13344,7 +13440,7 @@
         </p:nvGraphicFramePr>
         <p:xfrm>
           <a:off x="530352" y="2662428"/>
-          <a:ext cx="11130991" cy="2332736"/>
+          <a:ext cx="11130991" cy="1849120"/>
         </p:xfrm>
         <a:graphic>
           <a:graphicData uri="http://schemas.openxmlformats.org/drawingml/2006/table">
@@ -13427,7 +13523,7 @@
                           </a:solidFill>
                           <a:latin typeface="Calibri"/>
                         </a:rPr>
-                        <a:t>Open the notebook as it was saved on Friday night, scroll through the outputs and explain each chart.</a:t>
+                        <a:t>Skip the recovery and open the notebook as saved on Friday night, scrolling through its charts.</a:t>
                       </a:r>
                     </a:p>
                   </a:txBody>
@@ -13473,7 +13569,7 @@
                           </a:solidFill>
                           <a:latin typeface="Calibri"/>
                         </a:rPr>
-                        <a:t>Run a cleaned extract the group saved on Thursday, because the raw files take a minute to load.</a:t>
+                        <a:t>Switch to a cleaned extract the group saved on Thursday, since the raw files are what broke.</a:t>
                       </a:r>
                     </a:p>
                   </a:txBody>
@@ -13484,7 +13580,7 @@
                   </a:tcPr>
                 </a:tc>
               </a:tr>
-              <a:tr h="611632">
+              <a:tr h="369824">
                 <a:tc>
                   <a:txBody>
                     <a:bodyPr/>
@@ -13519,7 +13615,7 @@
                           </a:solidFill>
                           <a:latin typeface="Calibri"/>
                         </a:rPr>
-                        <a:t>Restart the kernel, run every cell once on the files in the data folder, and read the claim's number off the last cell.</a:t>
+                        <a:t>Keep debugging live for as long as it takes, so the panel sees every output in the end.</a:t>
                       </a:r>
                     </a:p>
                   </a:txBody>
@@ -13530,7 +13626,7 @@
                   </a:tcPr>
                 </a:tc>
               </a:tr>
-              <a:tr h="611632">
+              <a:tr h="369824">
                 <a:tc>
                   <a:txBody>
                     <a:bodyPr/>
@@ -13565,7 +13661,7 @@
                           </a:solidFill>
                           <a:latin typeface="Calibri"/>
                         </a:rPr>
-                        <a:t>Run it cold, and if one cell fails, fix that cell live and run the whole notebook again from the top so the panel sees every output.</a:t>
+                        <a:t>Fix the cell live inside two minutes; if it still fails, present from the executed notebook.</a:t>
                       </a:r>
                     </a:p>
                   </a:txBody>
@@ -14005,7 +14101,7 @@
                 </a:solidFill>
                 <a:latin typeface="Calibri"/>
               </a:rPr>
-              <a:t>S12  ·  17 / 24</a:t>
+              <a:t>S12  ·  17 / 25</a:t>
             </a:r>
           </a:p>
         </p:txBody>
@@ -14211,7 +14307,7 @@
                 </a:solidFill>
                 <a:latin typeface="Georgia"/>
               </a:rPr>
-              <a:t>Answer: c, and only c</a:t>
+              <a:t>Answer: d, a live fix inside two minutes</a:t>
             </a:r>
           </a:p>
         </p:txBody>
@@ -14246,7 +14342,7 @@
                 </a:solidFill>
                 <a:latin typeface="Calibri"/>
               </a:rPr>
-              <a:t>Each of the other three breaks one rule.</a:t>
+              <a:t>A client gives you two minutes to recover, and never an open-ended debugging session.</a:t>
             </a:r>
           </a:p>
         </p:txBody>
@@ -14354,7 +14450,7 @@
                           </a:solidFill>
                           <a:latin typeface="Calibri"/>
                         </a:rPr>
-                        <a:t>Cold: saved outputs are from an earlier run, so nothing ran in front of the panel</a:t>
+                        <a:t>Gives up the two minutes a client would allow, and shows outputs nothing ran in front of the panel</a:t>
                       </a:r>
                     </a:p>
                   </a:txBody>
@@ -14400,7 +14496,7 @@
                           </a:solidFill>
                           <a:latin typeface="Calibri"/>
                         </a:rPr>
-                        <a:t>Raw files: the extract hides every cleaning decision the panel wants to see made</a:t>
+                        <a:t>Breaks the raw files rule: the extract hides every cleaning decision the panel wants to see made</a:t>
                       </a:r>
                     </a:p>
                   </a:txBody>
@@ -14446,7 +14542,7 @@
                           </a:solidFill>
                           <a:latin typeface="Calibri"/>
                         </a:rPr>
-                        <a:t>Meets all three: cold, raw and once</a:t>
+                        <a:t>Breaks the two-minute limit: open-ended debugging eats the slot and the panel's questions</a:t>
                       </a:r>
                     </a:p>
                   </a:txBody>
@@ -14492,7 +14588,7 @@
                           </a:solidFill>
                           <a:latin typeface="Calibri"/>
                         </a:rPr>
-                        <a:t>One run: a live fix and a second run turn the demo into debugging</a:t>
+                        <a:t>Holds: two minutes to recover live, then the executed notebook, and the analysis keeps its marks</a:t>
                       </a:r>
                     </a:p>
                   </a:txBody>
@@ -14932,7 +15028,7 @@
                 </a:solidFill>
                 <a:latin typeface="Calibri"/>
               </a:rPr>
-              <a:t>S13  ·  18 / 24</a:t>
+              <a:t>S13  ·  18 / 25</a:t>
             </a:r>
           </a:p>
         </p:txBody>
@@ -15518,7 +15614,7 @@
                 </a:solidFill>
                 <a:latin typeface="Calibri"/>
               </a:rPr>
-              <a:t>Week 3, Build 1: the presentation</a:t>
+              <a:t>Your answer, in front of the panel</a:t>
             </a:r>
           </a:p>
         </p:txBody>
@@ -15553,7 +15649,7 @@
                 </a:solidFill>
                 <a:latin typeface="Calibri"/>
               </a:rPr>
-              <a:t>19 / 24</a:t>
+              <a:t>19 / 25</a:t>
             </a:r>
           </a:p>
         </p:txBody>
@@ -16139,7 +16235,7 @@
                 </a:solidFill>
                 <a:latin typeface="Calibri"/>
               </a:rPr>
-              <a:t>Week 3, Build 1: the presentation</a:t>
+              <a:t>Your answer, in front of the panel</a:t>
             </a:r>
           </a:p>
         </p:txBody>
@@ -16174,7 +16270,7 @@
                 </a:solidFill>
                 <a:latin typeface="Calibri"/>
               </a:rPr>
-              <a:t>2 / 24</a:t>
+              <a:t>2 / 25</a:t>
             </a:r>
           </a:p>
         </p:txBody>
@@ -17338,7 +17434,7 @@
                 </a:solidFill>
                 <a:latin typeface="Calibri"/>
               </a:rPr>
-              <a:t>S14  ·  20 / 24</a:t>
+              <a:t>S14  ·  20 / 25</a:t>
             </a:r>
           </a:p>
         </p:txBody>
@@ -18224,7 +18320,7 @@
                 </a:solidFill>
                 <a:latin typeface="Calibri"/>
               </a:rPr>
-              <a:t>S15  ·  21 / 24</a:t>
+              <a:t>S15  ·  21 / 25</a:t>
             </a:r>
           </a:p>
         </p:txBody>
@@ -19278,7 +19374,7 @@
                 </a:solidFill>
                 <a:latin typeface="Calibri"/>
               </a:rPr>
-              <a:t>S16  ·  22 / 24</a:t>
+              <a:t>S16  ·  22 / 25</a:t>
             </a:r>
           </a:p>
         </p:txBody>
@@ -20396,7 +20492,7 @@
                 </a:solidFill>
                 <a:latin typeface="Calibri"/>
               </a:rPr>
-              <a:t>S17  ·  23 / 24</a:t>
+              <a:t>S17  ·  23 / 25</a:t>
             </a:r>
           </a:p>
         </p:txBody>
@@ -21560,7 +21656,1250 @@
                 </a:solidFill>
                 <a:latin typeface="Calibri"/>
               </a:rPr>
-              <a:t>S18  ·  24 / 24</a:t>
+              <a:t>S18  ·  24 / 25</a:t>
+            </a:r>
+          </a:p>
+        </p:txBody>
+      </p:sp>
+    </p:spTree>
+  </p:cSld>
+  <p:clrMapOvr>
+    <a:masterClrMapping/>
+  </p:clrMapOvr>
+</p:sld>
+</file>
+
+<file path=ppt/slides/slide25.xml><?xml version="1.0" encoding="utf-8"?>
+<p:sld xmlns:a="http://schemas.openxmlformats.org/drawingml/2006/main" xmlns:p="http://schemas.openxmlformats.org/presentationml/2006/main" xmlns:r="http://schemas.openxmlformats.org/officeDocument/2006/relationships">
+  <p:cSld>
+    <p:spTree>
+      <p:nvGrpSpPr>
+        <p:cNvPr id="1" name=""/>
+        <p:cNvGrpSpPr/>
+        <p:nvPr/>
+      </p:nvGrpSpPr>
+      <p:grpSpPr/>
+      <p:pic>
+        <p:nvPicPr>
+          <p:cNvPr id="2" name="Picture 1" descr="bg_light.jpg"/>
+          <p:cNvPicPr>
+            <a:picLocks noChangeAspect="1"/>
+          </p:cNvPicPr>
+          <p:nvPr/>
+        </p:nvPicPr>
+        <p:blipFill>
+          <a:blip r:embed="rId2"/>
+          <a:stretch>
+            <a:fillRect/>
+          </a:stretch>
+        </p:blipFill>
+        <p:spPr>
+          <a:xfrm>
+            <a:off x="0" y="0"/>
+            <a:ext cx="12191695" cy="6858000"/>
+          </a:xfrm>
+          <a:prstGeom prst="rect">
+            <a:avLst/>
+          </a:prstGeom>
+        </p:spPr>
+      </p:pic>
+      <p:pic>
+        <p:nvPicPr>
+          <p:cNvPr id="3" name="Picture 2" descr="iitgn_logo.png"/>
+          <p:cNvPicPr>
+            <a:picLocks noChangeAspect="1"/>
+          </p:cNvPicPr>
+          <p:nvPr/>
+        </p:nvPicPr>
+        <p:blipFill>
+          <a:blip r:embed="rId3"/>
+          <a:stretch>
+            <a:fillRect/>
+          </a:stretch>
+        </p:blipFill>
+        <p:spPr>
+          <a:xfrm>
+            <a:off x="530352" y="201168"/>
+            <a:ext cx="420624" cy="420624"/>
+          </a:xfrm>
+          <a:prstGeom prst="rect">
+            <a:avLst/>
+          </a:prstGeom>
+        </p:spPr>
+      </p:pic>
+      <p:sp>
+        <p:nvSpPr>
+          <p:cNvPr id="4" name="TextBox 3"/>
+          <p:cNvSpPr txBox="1"/>
+          <p:nvPr/>
+        </p:nvSpPr>
+        <p:spPr>
+          <a:xfrm>
+            <a:off x="1042416" y="228600"/>
+            <a:ext cx="5120640" cy="185166"/>
+          </a:xfrm>
+          <a:prstGeom prst="rect">
+            <a:avLst/>
+          </a:prstGeom>
+          <a:noFill/>
+        </p:spPr>
+        <p:txBody>
+          <a:bodyPr wrap="square" anchor="t" lIns="0" rIns="0" tIns="0" bIns="0">
+            <a:spAutoFit/>
+          </a:bodyPr>
+          <a:lstStyle/>
+          <a:p>
+            <a:pPr algn="l"/>
+            <a:r>
+              <a:rPr sz="900" b="1" i="0">
+                <a:solidFill>
+                  <a:srgbClr val="1A0F5C"/>
+                </a:solidFill>
+                <a:latin typeface="Calibri"/>
+              </a:rPr>
+              <a:t>Indian Institute of Technology Gandhinagar</a:t>
+            </a:r>
+          </a:p>
+        </p:txBody>
+      </p:sp>
+      <p:sp>
+        <p:nvSpPr>
+          <p:cNvPr id="5" name="TextBox 4"/>
+          <p:cNvSpPr txBox="1"/>
+          <p:nvPr/>
+        </p:nvSpPr>
+        <p:spPr>
+          <a:xfrm>
+            <a:off x="1042416" y="420623"/>
+            <a:ext cx="5852160" cy="127381"/>
+          </a:xfrm>
+          <a:prstGeom prst="rect">
+            <a:avLst/>
+          </a:prstGeom>
+          <a:noFill/>
+        </p:spPr>
+        <p:txBody>
+          <a:bodyPr wrap="square" anchor="t" lIns="0" rIns="0" tIns="0" bIns="0">
+            <a:spAutoFit/>
+          </a:bodyPr>
+          <a:lstStyle/>
+          <a:p>
+            <a:pPr algn="l"/>
+            <a:r>
+              <a:rPr sz="550" b="1" i="0" spc="300">
+                <a:solidFill>
+                  <a:srgbClr val="6B6690"/>
+                </a:solidFill>
+                <a:latin typeface="Calibri"/>
+              </a:rPr>
+              <a:t>ADMINISTERED THROUGH THE COMPETENCY ADVANCEMENT ACADEMY</a:t>
+            </a:r>
+          </a:p>
+        </p:txBody>
+      </p:sp>
+      <p:sp>
+        <p:nvSpPr>
+          <p:cNvPr id="6" name="TextBox 5"/>
+          <p:cNvSpPr txBox="1"/>
+          <p:nvPr/>
+        </p:nvSpPr>
+        <p:spPr>
+          <a:xfrm>
+            <a:off x="5992063" y="310896"/>
+            <a:ext cx="5669280" cy="127381"/>
+          </a:xfrm>
+          <a:prstGeom prst="rect">
+            <a:avLst/>
+          </a:prstGeom>
+          <a:noFill/>
+        </p:spPr>
+        <p:txBody>
+          <a:bodyPr wrap="square" anchor="t" lIns="0" rIns="0" tIns="0" bIns="0">
+            <a:spAutoFit/>
+          </a:bodyPr>
+          <a:lstStyle/>
+          <a:p>
+            <a:pPr algn="r"/>
+            <a:r>
+              <a:rPr sz="550" b="1" i="0" spc="300">
+                <a:solidFill>
+                  <a:srgbClr val="6B6690"/>
+                </a:solidFill>
+                <a:latin typeface="Calibri"/>
+              </a:rPr>
+              <a:t>PG DIPLOMA IN AI-ML AND AGENTIC AI ENGINEERING  ·  COHORT 2</a:t>
+            </a:r>
+          </a:p>
+        </p:txBody>
+      </p:sp>
+      <p:sp>
+        <p:nvSpPr>
+          <p:cNvPr id="7" name="TextBox 6"/>
+          <p:cNvSpPr txBox="1"/>
+          <p:nvPr/>
+        </p:nvSpPr>
+        <p:spPr>
+          <a:xfrm>
+            <a:off x="530352" y="676656"/>
+            <a:ext cx="11130991" cy="512064"/>
+          </a:xfrm>
+          <a:prstGeom prst="rect">
+            <a:avLst/>
+          </a:prstGeom>
+          <a:noFill/>
+        </p:spPr>
+        <p:txBody>
+          <a:bodyPr wrap="square" anchor="b" lIns="0" rIns="0" tIns="0" bIns="0">
+            <a:spAutoFit/>
+          </a:bodyPr>
+          <a:lstStyle/>
+          <a:p>
+            <a:pPr algn="l"/>
+            <a:r>
+              <a:rPr sz="2600" b="0" i="0">
+                <a:solidFill>
+                  <a:srgbClr val="1A0F5C"/>
+                </a:solidFill>
+                <a:latin typeface="Georgia"/>
+              </a:rPr>
+              <a:t>How the mini project is scored</a:t>
+            </a:r>
+          </a:p>
+        </p:txBody>
+      </p:sp>
+      <p:sp>
+        <p:nvSpPr>
+          <p:cNvPr id="8" name="TextBox 7"/>
+          <p:cNvSpPr txBox="1"/>
+          <p:nvPr/>
+        </p:nvSpPr>
+        <p:spPr>
+          <a:xfrm>
+            <a:off x="530352" y="1243584"/>
+            <a:ext cx="11130991" cy="234696"/>
+          </a:xfrm>
+          <a:prstGeom prst="rect">
+            <a:avLst/>
+          </a:prstGeom>
+          <a:noFill/>
+        </p:spPr>
+        <p:txBody>
+          <a:bodyPr wrap="square" anchor="t" lIns="0" rIns="0" tIns="0" bIns="0">
+            <a:spAutoFit/>
+          </a:bodyPr>
+          <a:lstStyle/>
+          <a:p>
+            <a:pPr algn="l"/>
+            <a:r>
+              <a:rPr sz="1200" b="0" i="0">
+                <a:solidFill>
+                  <a:srgbClr val="6B6690"/>
+                </a:solidFill>
+                <a:latin typeface="Calibri"/>
+              </a:rPr>
+              <a:t>The approved rubric: 34 marks for the group's work and 6 for each learner's presentation and defence.</a:t>
+            </a:r>
+          </a:p>
+        </p:txBody>
+      </p:sp>
+      <p:sp>
+        <p:nvSpPr>
+          <p:cNvPr id="9" name="Rounded Rectangle 8"/>
+          <p:cNvSpPr/>
+          <p:nvPr/>
+        </p:nvSpPr>
+        <p:spPr>
+          <a:xfrm>
+            <a:off x="530352" y="1956816"/>
+            <a:ext cx="11130991" cy="736600"/>
+          </a:xfrm>
+          <a:prstGeom prst="roundRect">
+            <a:avLst>
+              <a:gd name="adj" fmla="val 8000"/>
+            </a:avLst>
+          </a:prstGeom>
+          <a:solidFill>
+            <a:srgbClr val="F7F5FD"/>
+          </a:solidFill>
+          <a:ln w="9525">
+            <a:solidFill>
+              <a:srgbClr val="E4E1F1"/>
+            </a:solidFill>
+          </a:ln>
+          <a:effectLst/>
+        </p:spPr>
+        <p:style>
+          <a:lnRef idx="1">
+            <a:schemeClr val="accent1"/>
+          </a:lnRef>
+          <a:fillRef idx="3">
+            <a:schemeClr val="accent1"/>
+          </a:fillRef>
+          <a:effectRef idx="2">
+            <a:schemeClr val="accent1"/>
+          </a:effectRef>
+          <a:fontRef idx="minor">
+            <a:schemeClr val="lt1"/>
+          </a:fontRef>
+        </p:style>
+        <p:txBody>
+          <a:bodyPr rtlCol="0" anchor="ctr" wrap="square"/>
+          <a:lstStyle/>
+          <a:p>
+            <a:pPr algn="ctr"/>
+          </a:p>
+        </p:txBody>
+      </p:sp>
+      <p:sp>
+        <p:nvSpPr>
+          <p:cNvPr id="10" name="Rounded Rectangle 9"/>
+          <p:cNvSpPr/>
+          <p:nvPr/>
+        </p:nvSpPr>
+        <p:spPr>
+          <a:xfrm>
+            <a:off x="676656" y="2084832"/>
+            <a:ext cx="45720" cy="480568"/>
+          </a:xfrm>
+          <a:prstGeom prst="roundRect">
+            <a:avLst>
+              <a:gd name="adj" fmla="val 50000"/>
+            </a:avLst>
+          </a:prstGeom>
+          <a:solidFill>
+            <a:srgbClr val="5B3FD6"/>
+          </a:solidFill>
+          <a:ln>
+            <a:noFill/>
+          </a:ln>
+          <a:effectLst/>
+        </p:spPr>
+        <p:style>
+          <a:lnRef idx="1">
+            <a:schemeClr val="accent1"/>
+          </a:lnRef>
+          <a:fillRef idx="3">
+            <a:schemeClr val="accent1"/>
+          </a:fillRef>
+          <a:effectRef idx="2">
+            <a:schemeClr val="accent1"/>
+          </a:effectRef>
+          <a:fontRef idx="minor">
+            <a:schemeClr val="lt1"/>
+          </a:fontRef>
+        </p:style>
+        <p:txBody>
+          <a:bodyPr rtlCol="0" anchor="ctr" wrap="square"/>
+          <a:lstStyle/>
+          <a:p>
+            <a:pPr algn="ctr"/>
+          </a:p>
+        </p:txBody>
+      </p:sp>
+      <p:sp>
+        <p:nvSpPr>
+          <p:cNvPr id="11" name="TextBox 10"/>
+          <p:cNvSpPr txBox="1"/>
+          <p:nvPr/>
+        </p:nvSpPr>
+        <p:spPr>
+          <a:xfrm>
+            <a:off x="877824" y="2075688"/>
+            <a:ext cx="10564063" cy="553720"/>
+          </a:xfrm>
+          <a:prstGeom prst="rect">
+            <a:avLst/>
+          </a:prstGeom>
+          <a:noFill/>
+        </p:spPr>
+        <p:txBody>
+          <a:bodyPr wrap="square" anchor="ctr" lIns="0" rIns="0" tIns="0" bIns="0">
+            <a:spAutoFit/>
+          </a:bodyPr>
+          <a:lstStyle/>
+          <a:p>
+            <a:r>
+              <a:rPr sz="1300" b="1">
+                <a:solidFill>
+                  <a:srgbClr val="5B3FD6"/>
+                </a:solidFill>
+                <a:latin typeface="Calibri"/>
+              </a:rPr>
+              <a:t>Mini project, 40 marks. </a:t>
+            </a:r>
+            <a:r>
+              <a:rPr sz="1300" b="0" i="0">
+                <a:solidFill>
+                  <a:srgbClr val="1A1440"/>
+                </a:solidFill>
+                <a:latin typeface="Calibri"/>
+              </a:rPr>
+              <a:t>The first four criteria are scored once for the group, and every member receives those 34 marks; presentation and defence is scored for each learner on 6 marks, so a silent teammate cannot ride the group's score.</a:t>
+            </a:r>
+          </a:p>
+        </p:txBody>
+      </p:sp>
+      <p:graphicFrame>
+        <p:nvGraphicFramePr>
+          <p:cNvPr id="12" name="Table 11"/>
+          <p:cNvGraphicFramePr>
+            <a:graphicFrameLocks noGrp="1"/>
+          </p:cNvGraphicFramePr>
+          <p:nvPr/>
+        </p:nvGraphicFramePr>
+        <p:xfrm>
+          <a:off x="530352" y="2858008"/>
+          <a:ext cx="11130990" cy="2840736"/>
+        </p:xfrm>
+        <a:graphic>
+          <a:graphicData uri="http://schemas.openxmlformats.org/drawingml/2006/table">
+            <a:tbl>
+              <a:tblPr firstRow="0" bandRow="0">
+                <a:tableStyleId>{2D5ABB26-0587-4C30-8999-92F81FD0307C}</a:tableStyleId>
+              </a:tblPr>
+              <a:tblGrid>
+                <a:gridCol w="2886034"/>
+                <a:gridCol w="914400"/>
+                <a:gridCol w="7330556"/>
+              </a:tblGrid>
+              <a:tr h="335280">
+                <a:tc>
+                  <a:txBody>
+                    <a:bodyPr/>
+                    <a:lstStyle/>
+                    <a:p>
+                      <a:r>
+                        <a:rPr sz="1250" b="1" i="0">
+                          <a:solidFill>
+                            <a:srgbClr val="FFFFFF"/>
+                          </a:solidFill>
+                          <a:latin typeface="Calibri"/>
+                        </a:rPr>
+                        <a:t>Criterion</a:t>
+                      </a:r>
+                    </a:p>
+                  </a:txBody>
+                  <a:tcPr marL="101600" marR="101600" marT="38100" marB="38100" anchor="ctr">
+                    <a:solidFill>
+                      <a:srgbClr val="1A0F5C"/>
+                    </a:solidFill>
+                  </a:tcPr>
+                </a:tc>
+                <a:tc>
+                  <a:txBody>
+                    <a:bodyPr/>
+                    <a:lstStyle/>
+                    <a:p>
+                      <a:r>
+                        <a:rPr sz="1250" b="1" i="0">
+                          <a:solidFill>
+                            <a:srgbClr val="FFFFFF"/>
+                          </a:solidFill>
+                          <a:latin typeface="Calibri"/>
+                        </a:rPr>
+                        <a:t>Marks</a:t>
+                      </a:r>
+                    </a:p>
+                  </a:txBody>
+                  <a:tcPr marL="101600" marR="101600" marT="38100" marB="38100" anchor="ctr">
+                    <a:solidFill>
+                      <a:srgbClr val="1A0F5C"/>
+                    </a:solidFill>
+                  </a:tcPr>
+                </a:tc>
+                <a:tc>
+                  <a:txBody>
+                    <a:bodyPr/>
+                    <a:lstStyle/>
+                    <a:p>
+                      <a:r>
+                        <a:rPr sz="1250" b="1" i="0">
+                          <a:solidFill>
+                            <a:srgbClr val="FFFFFF"/>
+                          </a:solidFill>
+                          <a:latin typeface="Calibri"/>
+                        </a:rPr>
+                        <a:t>What full marks look like</a:t>
+                      </a:r>
+                    </a:p>
+                  </a:txBody>
+                  <a:tcPr marL="101600" marR="101600" marT="38100" marB="38100" anchor="ctr">
+                    <a:solidFill>
+                      <a:srgbClr val="1A0F5C"/>
+                    </a:solidFill>
+                  </a:tcPr>
+                </a:tc>
+              </a:tr>
+              <a:tr h="542544">
+                <a:tc>
+                  <a:txBody>
+                    <a:bodyPr/>
+                    <a:lstStyle/>
+                    <a:p>
+                      <a:r>
+                        <a:rPr sz="1200" b="0" i="0">
+                          <a:solidFill>
+                            <a:srgbClr val="1A1440"/>
+                          </a:solidFill>
+                          <a:latin typeface="Calibri"/>
+                        </a:rPr>
+                        <a:t>The question translated</a:t>
+                      </a:r>
+                    </a:p>
+                  </a:txBody>
+                  <a:tcPr marL="101600" marR="101600" marT="38100" marB="38100" anchor="ctr">
+                    <a:solidFill>
+                      <a:srgbClr val="FFFFFF"/>
+                    </a:solidFill>
+                  </a:tcPr>
+                </a:tc>
+                <a:tc>
+                  <a:txBody>
+                    <a:bodyPr/>
+                    <a:lstStyle/>
+                    <a:p>
+                      <a:r>
+                        <a:rPr sz="1200" b="0" i="0">
+                          <a:solidFill>
+                            <a:srgbClr val="1A1440"/>
+                          </a:solidFill>
+                          <a:latin typeface="Calibri"/>
+                        </a:rPr>
+                        <a:t>8</a:t>
+                      </a:r>
+                    </a:p>
+                  </a:txBody>
+                  <a:tcPr marL="101600" marR="101600" marT="38100" marB="38100" anchor="ctr">
+                    <a:solidFill>
+                      <a:srgbClr val="FFFFFF"/>
+                    </a:solidFill>
+                  </a:tcPr>
+                </a:tc>
+                <a:tc>
+                  <a:txBody>
+                    <a:bodyPr/>
+                    <a:lstStyle/>
+                    <a:p>
+                      <a:r>
+                        <a:rPr sz="1200" b="0" i="0">
+                          <a:solidFill>
+                            <a:srgbClr val="1A1440"/>
+                          </a:solidFill>
+                          <a:latin typeface="Calibri"/>
+                        </a:rPr>
+                        <a:t>Dr Menon's words are mapped to the right Weeks 1 and 2 method, with the metric defined and the decision it feeds named.</a:t>
+                      </a:r>
+                    </a:p>
+                  </a:txBody>
+                  <a:tcPr marL="101600" marR="101600" marT="38100" marB="38100" anchor="ctr">
+                    <a:solidFill>
+                      <a:srgbClr val="FFFFFF"/>
+                    </a:solidFill>
+                  </a:tcPr>
+                </a:tc>
+              </a:tr>
+              <a:tr h="542544">
+                <a:tc>
+                  <a:txBody>
+                    <a:bodyPr/>
+                    <a:lstStyle/>
+                    <a:p>
+                      <a:r>
+                        <a:rPr sz="1200" b="0" i="0">
+                          <a:solidFill>
+                            <a:srgbClr val="1A1440"/>
+                          </a:solidFill>
+                          <a:latin typeface="Calibri"/>
+                        </a:rPr>
+                        <a:t>The data made trustworthy</a:t>
+                      </a:r>
+                    </a:p>
+                  </a:txBody>
+                  <a:tcPr marL="101600" marR="101600" marT="38100" marB="38100" anchor="ctr">
+                    <a:solidFill>
+                      <a:srgbClr val="F4F2FA"/>
+                    </a:solidFill>
+                  </a:tcPr>
+                </a:tc>
+                <a:tc>
+                  <a:txBody>
+                    <a:bodyPr/>
+                    <a:lstStyle/>
+                    <a:p>
+                      <a:r>
+                        <a:rPr sz="1200" b="0" i="0">
+                          <a:solidFill>
+                            <a:srgbClr val="1A1440"/>
+                          </a:solidFill>
+                          <a:latin typeface="Calibri"/>
+                        </a:rPr>
+                        <a:t>10</a:t>
+                      </a:r>
+                    </a:p>
+                  </a:txBody>
+                  <a:tcPr marL="101600" marR="101600" marT="38100" marB="38100" anchor="ctr">
+                    <a:solidFill>
+                      <a:srgbClr val="F4F2FA"/>
+                    </a:solidFill>
+                  </a:tcPr>
+                </a:tc>
+                <a:tc>
+                  <a:txBody>
+                    <a:bodyPr/>
+                    <a:lstStyle/>
+                    <a:p>
+                      <a:r>
+                        <a:rPr sz="1200" b="0" i="0">
+                          <a:solidFill>
+                            <a:srgbClr val="1A1440"/>
+                          </a:solidFill>
+                          <a:latin typeface="Calibri"/>
+                        </a:rPr>
+                        <a:t>The data is profiled before it is touched, every cleaning call is in the decisions log with its reason, and counts and rupees reconcile across files.</a:t>
+                      </a:r>
+                    </a:p>
+                  </a:txBody>
+                  <a:tcPr marL="101600" marR="101600" marT="38100" marB="38100" anchor="ctr">
+                    <a:solidFill>
+                      <a:srgbClr val="F4F2FA"/>
+                    </a:solidFill>
+                  </a:tcPr>
+                </a:tc>
+              </a:tr>
+              <a:tr h="542544">
+                <a:tc>
+                  <a:txBody>
+                    <a:bodyPr/>
+                    <a:lstStyle/>
+                    <a:p>
+                      <a:r>
+                        <a:rPr sz="1200" b="0" i="0">
+                          <a:solidFill>
+                            <a:srgbClr val="1A1440"/>
+                          </a:solidFill>
+                          <a:latin typeface="Calibri"/>
+                        </a:rPr>
+                        <a:t>The analysis</a:t>
+                      </a:r>
+                    </a:p>
+                  </a:txBody>
+                  <a:tcPr marL="101600" marR="101600" marT="38100" marB="38100" anchor="ctr">
+                    <a:solidFill>
+                      <a:srgbClr val="FFFFFF"/>
+                    </a:solidFill>
+                  </a:tcPr>
+                </a:tc>
+                <a:tc>
+                  <a:txBody>
+                    <a:bodyPr/>
+                    <a:lstStyle/>
+                    <a:p>
+                      <a:r>
+                        <a:rPr sz="1200" b="0" i="0">
+                          <a:solidFill>
+                            <a:srgbClr val="1A1440"/>
+                          </a:solidFill>
+                          <a:latin typeface="Calibri"/>
+                        </a:rPr>
+                        <a:t>10</a:t>
+                      </a:r>
+                    </a:p>
+                  </a:txBody>
+                  <a:tcPr marL="101600" marR="101600" marT="38100" marB="38100" anchor="ctr">
+                    <a:solidFill>
+                      <a:srgbClr val="FFFFFF"/>
+                    </a:solidFill>
+                  </a:tcPr>
+                </a:tc>
+                <a:tc>
+                  <a:txBody>
+                    <a:bodyPr/>
+                    <a:lstStyle/>
+                    <a:p>
+                      <a:r>
+                        <a:rPr sz="1200" b="0" i="0">
+                          <a:solidFill>
+                            <a:srgbClr val="1A1440"/>
+                          </a:solidFill>
+                          <a:latin typeface="Calibri"/>
+                        </a:rPr>
+                        <a:t>The tree, ladder or fair comparison reaches the branch that explains the symptom, on the right denominator, with a chance test where one is needed.</a:t>
+                      </a:r>
+                    </a:p>
+                  </a:txBody>
+                  <a:tcPr marL="101600" marR="101600" marT="38100" marB="38100" anchor="ctr">
+                    <a:solidFill>
+                      <a:srgbClr val="FFFFFF"/>
+                    </a:solidFill>
+                  </a:tcPr>
+                </a:tc>
+              </a:tr>
+              <a:tr h="542544">
+                <a:tc>
+                  <a:txBody>
+                    <a:bodyPr/>
+                    <a:lstStyle/>
+                    <a:p>
+                      <a:r>
+                        <a:rPr sz="1200" b="0" i="0">
+                          <a:solidFill>
+                            <a:srgbClr val="1A1440"/>
+                          </a:solidFill>
+                          <a:latin typeface="Calibri"/>
+                        </a:rPr>
+                        <a:t>The claim</a:t>
+                      </a:r>
+                    </a:p>
+                  </a:txBody>
+                  <a:tcPr marL="101600" marR="101600" marT="38100" marB="38100" anchor="ctr">
+                    <a:solidFill>
+                      <a:srgbClr val="F4F2FA"/>
+                    </a:solidFill>
+                  </a:tcPr>
+                </a:tc>
+                <a:tc>
+                  <a:txBody>
+                    <a:bodyPr/>
+                    <a:lstStyle/>
+                    <a:p>
+                      <a:r>
+                        <a:rPr sz="1200" b="0" i="0">
+                          <a:solidFill>
+                            <a:srgbClr val="1A1440"/>
+                          </a:solidFill>
+                          <a:latin typeface="Calibri"/>
+                        </a:rPr>
+                        <a:t>6</a:t>
+                      </a:r>
+                    </a:p>
+                  </a:txBody>
+                  <a:tcPr marL="101600" marR="101600" marT="38100" marB="38100" anchor="ctr">
+                    <a:solidFill>
+                      <a:srgbClr val="F4F2FA"/>
+                    </a:solidFill>
+                  </a:tcPr>
+                </a:tc>
+                <a:tc>
+                  <a:txBody>
+                    <a:bodyPr/>
+                    <a:lstStyle/>
+                    <a:p>
+                      <a:r>
+                        <a:rPr sz="1200" b="0" i="0">
+                          <a:solidFill>
+                            <a:srgbClr val="1A1440"/>
+                          </a:solidFill>
+                          <a:latin typeface="Calibri"/>
+                        </a:rPr>
+                        <a:t>One sentence carries its number, denominator, period and caveat, plus an action Dr Menon can take.</a:t>
+                      </a:r>
+                    </a:p>
+                  </a:txBody>
+                  <a:tcPr marL="101600" marR="101600" marT="38100" marB="38100" anchor="ctr">
+                    <a:solidFill>
+                      <a:srgbClr val="F4F2FA"/>
+                    </a:solidFill>
+                  </a:tcPr>
+                </a:tc>
+              </a:tr>
+              <a:tr h="335280">
+                <a:tc>
+                  <a:txBody>
+                    <a:bodyPr/>
+                    <a:lstStyle/>
+                    <a:p>
+                      <a:r>
+                        <a:rPr sz="1200" b="0" i="0">
+                          <a:solidFill>
+                            <a:srgbClr val="1A1440"/>
+                          </a:solidFill>
+                          <a:latin typeface="Calibri"/>
+                        </a:rPr>
+                        <a:t>Presentation and defence</a:t>
+                      </a:r>
+                    </a:p>
+                  </a:txBody>
+                  <a:tcPr marL="101600" marR="101600" marT="38100" marB="38100" anchor="ctr">
+                    <a:solidFill>
+                      <a:srgbClr val="FFFFFF"/>
+                    </a:solidFill>
+                  </a:tcPr>
+                </a:tc>
+                <a:tc>
+                  <a:txBody>
+                    <a:bodyPr/>
+                    <a:lstStyle/>
+                    <a:p>
+                      <a:r>
+                        <a:rPr sz="1200" b="0" i="0">
+                          <a:solidFill>
+                            <a:srgbClr val="1A1440"/>
+                          </a:solidFill>
+                          <a:latin typeface="Calibri"/>
+                        </a:rPr>
+                        <a:t>6</a:t>
+                      </a:r>
+                    </a:p>
+                  </a:txBody>
+                  <a:tcPr marL="101600" marR="101600" marT="38100" marB="38100" anchor="ctr">
+                    <a:solidFill>
+                      <a:srgbClr val="FFFFFF"/>
+                    </a:solidFill>
+                  </a:tcPr>
+                </a:tc>
+                <a:tc>
+                  <a:txBody>
+                    <a:bodyPr/>
+                    <a:lstStyle/>
+                    <a:p>
+                      <a:r>
+                        <a:rPr sz="1200" b="0" i="0">
+                          <a:solidFill>
+                            <a:srgbClr val="1A1440"/>
+                          </a:solidFill>
+                          <a:latin typeface="Calibri"/>
+                        </a:rPr>
+                        <a:t>The live demo runs cold, and every member answers a challenge on the caveat.</a:t>
+                      </a:r>
+                    </a:p>
+                  </a:txBody>
+                  <a:tcPr marL="101600" marR="101600" marT="38100" marB="38100" anchor="ctr">
+                    <a:solidFill>
+                      <a:srgbClr val="FFFFFF"/>
+                    </a:solidFill>
+                  </a:tcPr>
+                </a:tc>
+              </a:tr>
+            </a:tbl>
+          </a:graphicData>
+        </a:graphic>
+      </p:graphicFrame>
+      <p:sp>
+        <p:nvSpPr>
+          <p:cNvPr id="13" name="Oval 12"/>
+          <p:cNvSpPr/>
+          <p:nvPr/>
+        </p:nvSpPr>
+        <p:spPr>
+          <a:xfrm>
+            <a:off x="530352" y="6492240"/>
+            <a:ext cx="64008" cy="64008"/>
+          </a:xfrm>
+          <a:prstGeom prst="ellipse">
+            <a:avLst/>
+          </a:prstGeom>
+          <a:solidFill>
+            <a:srgbClr val="CFC9EE"/>
+          </a:solidFill>
+          <a:ln>
+            <a:noFill/>
+          </a:ln>
+          <a:effectLst/>
+        </p:spPr>
+        <p:style>
+          <a:lnRef idx="1">
+            <a:schemeClr val="accent1"/>
+          </a:lnRef>
+          <a:fillRef idx="3">
+            <a:schemeClr val="accent1"/>
+          </a:fillRef>
+          <a:effectRef idx="2">
+            <a:schemeClr val="accent1"/>
+          </a:effectRef>
+          <a:fontRef idx="minor">
+            <a:schemeClr val="lt1"/>
+          </a:fontRef>
+        </p:style>
+        <p:txBody>
+          <a:bodyPr rtlCol="0" anchor="ctr" wrap="square"/>
+          <a:lstStyle/>
+          <a:p>
+            <a:pPr algn="ctr"/>
+          </a:p>
+        </p:txBody>
+      </p:sp>
+      <p:sp>
+        <p:nvSpPr>
+          <p:cNvPr id="14" name="TextBox 13"/>
+          <p:cNvSpPr txBox="1"/>
+          <p:nvPr/>
+        </p:nvSpPr>
+        <p:spPr>
+          <a:xfrm>
+            <a:off x="640080" y="6437376"/>
+            <a:ext cx="1102423" cy="152146"/>
+          </a:xfrm>
+          <a:prstGeom prst="rect">
+            <a:avLst/>
+          </a:prstGeom>
+          <a:noFill/>
+        </p:spPr>
+        <p:txBody>
+          <a:bodyPr wrap="square" anchor="t" lIns="0" rIns="0" tIns="0" bIns="0">
+            <a:spAutoFit/>
+          </a:bodyPr>
+          <a:lstStyle/>
+          <a:p>
+            <a:pPr algn="l"/>
+            <a:r>
+              <a:rPr sz="700" b="0" i="0">
+                <a:solidFill>
+                  <a:srgbClr val="6B6690"/>
+                </a:solidFill>
+                <a:latin typeface="Calibri"/>
+              </a:rPr>
+              <a:t>The ask on the day</a:t>
+            </a:r>
+          </a:p>
+        </p:txBody>
+      </p:sp>
+      <p:sp>
+        <p:nvSpPr>
+          <p:cNvPr id="15" name="Oval 14"/>
+          <p:cNvSpPr/>
+          <p:nvPr/>
+        </p:nvSpPr>
+        <p:spPr>
+          <a:xfrm>
+            <a:off x="1833943" y="6492240"/>
+            <a:ext cx="64008" cy="64008"/>
+          </a:xfrm>
+          <a:prstGeom prst="ellipse">
+            <a:avLst/>
+          </a:prstGeom>
+          <a:solidFill>
+            <a:srgbClr val="CFC9EE"/>
+          </a:solidFill>
+          <a:ln>
+            <a:noFill/>
+          </a:ln>
+          <a:effectLst/>
+        </p:spPr>
+        <p:style>
+          <a:lnRef idx="1">
+            <a:schemeClr val="accent1"/>
+          </a:lnRef>
+          <a:fillRef idx="3">
+            <a:schemeClr val="accent1"/>
+          </a:fillRef>
+          <a:effectRef idx="2">
+            <a:schemeClr val="accent1"/>
+          </a:effectRef>
+          <a:fontRef idx="minor">
+            <a:schemeClr val="lt1"/>
+          </a:fontRef>
+        </p:style>
+        <p:txBody>
+          <a:bodyPr rtlCol="0" anchor="ctr" wrap="square"/>
+          <a:lstStyle/>
+          <a:p>
+            <a:pPr algn="ctr"/>
+          </a:p>
+        </p:txBody>
+      </p:sp>
+      <p:sp>
+        <p:nvSpPr>
+          <p:cNvPr id="16" name="TextBox 15"/>
+          <p:cNvSpPr txBox="1"/>
+          <p:nvPr/>
+        </p:nvSpPr>
+        <p:spPr>
+          <a:xfrm>
+            <a:off x="1943671" y="6437376"/>
+            <a:ext cx="1194435" cy="152146"/>
+          </a:xfrm>
+          <a:prstGeom prst="rect">
+            <a:avLst/>
+          </a:prstGeom>
+          <a:noFill/>
+        </p:spPr>
+        <p:txBody>
+          <a:bodyPr wrap="square" anchor="t" lIns="0" rIns="0" tIns="0" bIns="0">
+            <a:spAutoFit/>
+          </a:bodyPr>
+          <a:lstStyle/>
+          <a:p>
+            <a:pPr algn="l"/>
+            <a:r>
+              <a:rPr sz="700" b="0" i="0">
+                <a:solidFill>
+                  <a:srgbClr val="6B6690"/>
+                </a:solidFill>
+                <a:latin typeface="Calibri"/>
+              </a:rPr>
+              <a:t>The one-slide answer</a:t>
+            </a:r>
+          </a:p>
+        </p:txBody>
+      </p:sp>
+      <p:sp>
+        <p:nvSpPr>
+          <p:cNvPr id="17" name="Oval 16"/>
+          <p:cNvSpPr/>
+          <p:nvPr/>
+        </p:nvSpPr>
+        <p:spPr>
+          <a:xfrm>
+            <a:off x="3229546" y="6492240"/>
+            <a:ext cx="64008" cy="64008"/>
+          </a:xfrm>
+          <a:prstGeom prst="ellipse">
+            <a:avLst/>
+          </a:prstGeom>
+          <a:solidFill>
+            <a:srgbClr val="CFC9EE"/>
+          </a:solidFill>
+          <a:ln>
+            <a:noFill/>
+          </a:ln>
+          <a:effectLst/>
+        </p:spPr>
+        <p:style>
+          <a:lnRef idx="1">
+            <a:schemeClr val="accent1"/>
+          </a:lnRef>
+          <a:fillRef idx="3">
+            <a:schemeClr val="accent1"/>
+          </a:fillRef>
+          <a:effectRef idx="2">
+            <a:schemeClr val="accent1"/>
+          </a:effectRef>
+          <a:fontRef idx="minor">
+            <a:schemeClr val="lt1"/>
+          </a:fontRef>
+        </p:style>
+        <p:txBody>
+          <a:bodyPr rtlCol="0" anchor="ctr" wrap="square"/>
+          <a:lstStyle/>
+          <a:p>
+            <a:pPr algn="ctr"/>
+          </a:p>
+        </p:txBody>
+      </p:sp>
+      <p:sp>
+        <p:nvSpPr>
+          <p:cNvPr id="18" name="TextBox 17"/>
+          <p:cNvSpPr txBox="1"/>
+          <p:nvPr/>
+        </p:nvSpPr>
+        <p:spPr>
+          <a:xfrm>
+            <a:off x="3339274" y="6437376"/>
+            <a:ext cx="1194435" cy="152146"/>
+          </a:xfrm>
+          <a:prstGeom prst="rect">
+            <a:avLst/>
+          </a:prstGeom>
+          <a:noFill/>
+        </p:spPr>
+        <p:txBody>
+          <a:bodyPr wrap="square" anchor="t" lIns="0" rIns="0" tIns="0" bIns="0">
+            <a:spAutoFit/>
+          </a:bodyPr>
+          <a:lstStyle/>
+          <a:p>
+            <a:pPr algn="l"/>
+            <a:r>
+              <a:rPr sz="700" b="0" i="0">
+                <a:solidFill>
+                  <a:srgbClr val="6B6690"/>
+                </a:solidFill>
+                <a:latin typeface="Calibri"/>
+              </a:rPr>
+              <a:t>The body of the slot</a:t>
+            </a:r>
+          </a:p>
+        </p:txBody>
+      </p:sp>
+      <p:sp>
+        <p:nvSpPr>
+          <p:cNvPr id="19" name="Oval 18"/>
+          <p:cNvSpPr/>
+          <p:nvPr/>
+        </p:nvSpPr>
+        <p:spPr>
+          <a:xfrm>
+            <a:off x="4625149" y="6492240"/>
+            <a:ext cx="64008" cy="64008"/>
+          </a:xfrm>
+          <a:prstGeom prst="ellipse">
+            <a:avLst/>
+          </a:prstGeom>
+          <a:solidFill>
+            <a:srgbClr val="CFC9EE"/>
+          </a:solidFill>
+          <a:ln>
+            <a:noFill/>
+          </a:ln>
+          <a:effectLst/>
+        </p:spPr>
+        <p:style>
+          <a:lnRef idx="1">
+            <a:schemeClr val="accent1"/>
+          </a:lnRef>
+          <a:fillRef idx="3">
+            <a:schemeClr val="accent1"/>
+          </a:fillRef>
+          <a:effectRef idx="2">
+            <a:schemeClr val="accent1"/>
+          </a:effectRef>
+          <a:fontRef idx="minor">
+            <a:schemeClr val="lt1"/>
+          </a:fontRef>
+        </p:style>
+        <p:txBody>
+          <a:bodyPr rtlCol="0" anchor="ctr" wrap="square"/>
+          <a:lstStyle/>
+          <a:p>
+            <a:pPr algn="ctr"/>
+          </a:p>
+        </p:txBody>
+      </p:sp>
+      <p:sp>
+        <p:nvSpPr>
+          <p:cNvPr id="20" name="TextBox 19"/>
+          <p:cNvSpPr txBox="1"/>
+          <p:nvPr/>
+        </p:nvSpPr>
+        <p:spPr>
+          <a:xfrm>
+            <a:off x="4734877" y="6437376"/>
+            <a:ext cx="872394" cy="152146"/>
+          </a:xfrm>
+          <a:prstGeom prst="rect">
+            <a:avLst/>
+          </a:prstGeom>
+          <a:noFill/>
+        </p:spPr>
+        <p:txBody>
+          <a:bodyPr wrap="square" anchor="t" lIns="0" rIns="0" tIns="0" bIns="0">
+            <a:spAutoFit/>
+          </a:bodyPr>
+          <a:lstStyle/>
+          <a:p>
+            <a:pPr algn="l"/>
+            <a:r>
+              <a:rPr sz="700" b="0" i="0">
+                <a:solidFill>
+                  <a:srgbClr val="6B6690"/>
+                </a:solidFill>
+                <a:latin typeface="Calibri"/>
+              </a:rPr>
+              <a:t>The live demo</a:t>
+            </a:r>
+          </a:p>
+        </p:txBody>
+      </p:sp>
+      <p:sp>
+        <p:nvSpPr>
+          <p:cNvPr id="21" name="Oval 20"/>
+          <p:cNvSpPr/>
+          <p:nvPr/>
+        </p:nvSpPr>
+        <p:spPr>
+          <a:xfrm>
+            <a:off x="5698712" y="6492240"/>
+            <a:ext cx="64008" cy="64008"/>
+          </a:xfrm>
+          <a:prstGeom prst="ellipse">
+            <a:avLst/>
+          </a:prstGeom>
+          <a:solidFill>
+            <a:srgbClr val="5B3FD6"/>
+          </a:solidFill>
+          <a:ln>
+            <a:noFill/>
+          </a:ln>
+          <a:effectLst/>
+        </p:spPr>
+        <p:style>
+          <a:lnRef idx="1">
+            <a:schemeClr val="accent1"/>
+          </a:lnRef>
+          <a:fillRef idx="3">
+            <a:schemeClr val="accent1"/>
+          </a:fillRef>
+          <a:effectRef idx="2">
+            <a:schemeClr val="accent1"/>
+          </a:effectRef>
+          <a:fontRef idx="minor">
+            <a:schemeClr val="lt1"/>
+          </a:fontRef>
+        </p:style>
+        <p:txBody>
+          <a:bodyPr rtlCol="0" anchor="ctr" wrap="square"/>
+          <a:lstStyle/>
+          <a:p>
+            <a:pPr algn="ctr"/>
+          </a:p>
+        </p:txBody>
+      </p:sp>
+      <p:sp>
+        <p:nvSpPr>
+          <p:cNvPr id="22" name="TextBox 21"/>
+          <p:cNvSpPr txBox="1"/>
+          <p:nvPr/>
+        </p:nvSpPr>
+        <p:spPr>
+          <a:xfrm>
+            <a:off x="5808440" y="6437376"/>
+            <a:ext cx="1240440" cy="152146"/>
+          </a:xfrm>
+          <a:prstGeom prst="rect">
+            <a:avLst/>
+          </a:prstGeom>
+          <a:noFill/>
+        </p:spPr>
+        <p:txBody>
+          <a:bodyPr wrap="square" anchor="t" lIns="0" rIns="0" tIns="0" bIns="0">
+            <a:spAutoFit/>
+          </a:bodyPr>
+          <a:lstStyle/>
+          <a:p>
+            <a:pPr algn="l"/>
+            <a:r>
+              <a:rPr sz="700" b="1" i="0">
+                <a:solidFill>
+                  <a:srgbClr val="5B3FD6"/>
+                </a:solidFill>
+                <a:latin typeface="Calibri"/>
+              </a:rPr>
+              <a:t>The panel's questions</a:t>
+            </a:r>
+          </a:p>
+        </p:txBody>
+      </p:sp>
+      <p:sp>
+        <p:nvSpPr>
+          <p:cNvPr id="23" name="TextBox 22"/>
+          <p:cNvSpPr txBox="1"/>
+          <p:nvPr/>
+        </p:nvSpPr>
+        <p:spPr>
+          <a:xfrm>
+            <a:off x="10198303" y="6437376"/>
+            <a:ext cx="1463040" cy="160401"/>
+          </a:xfrm>
+          <a:prstGeom prst="rect">
+            <a:avLst/>
+          </a:prstGeom>
+          <a:noFill/>
+        </p:spPr>
+        <p:txBody>
+          <a:bodyPr wrap="square" anchor="t" lIns="0" rIns="0" tIns="0" bIns="0">
+            <a:spAutoFit/>
+          </a:bodyPr>
+          <a:lstStyle/>
+          <a:p>
+            <a:pPr algn="r"/>
+            <a:r>
+              <a:rPr sz="750" b="0" i="0">
+                <a:solidFill>
+                  <a:srgbClr val="6B6690"/>
+                </a:solidFill>
+                <a:latin typeface="Calibri"/>
+              </a:rPr>
+              <a:t>S19  ·  25 / 25</a:t>
             </a:r>
           </a:p>
         </p:txBody>
@@ -22684,7 +24023,7 @@
                 </a:solidFill>
                 <a:latin typeface="Calibri"/>
               </a:rPr>
-              <a:t>S1  ·  3 / 24</a:t>
+              <a:t>S1  ·  3 / 25</a:t>
             </a:r>
           </a:p>
         </p:txBody>
@@ -24088,7 +25427,7 @@
                 </a:solidFill>
                 <a:latin typeface="Calibri"/>
               </a:rPr>
-              <a:t>S2  ·  4 / 24</a:t>
+              <a:t>S2  ·  4 / 25</a:t>
             </a:r>
           </a:p>
         </p:txBody>
@@ -25286,7 +26625,7 @@
                 </a:solidFill>
                 <a:latin typeface="Calibri"/>
               </a:rPr>
-              <a:t>S3  ·  5 / 24</a:t>
+              <a:t>S3  ·  5 / 25</a:t>
             </a:r>
           </a:p>
         </p:txBody>
@@ -25872,7 +27211,7 @@
                 </a:solidFill>
                 <a:latin typeface="Calibri"/>
               </a:rPr>
-              <a:t>Week 3, Build 1: the presentation</a:t>
+              <a:t>Your answer, in front of the panel</a:t>
             </a:r>
           </a:p>
         </p:txBody>
@@ -25907,7 +27246,7 @@
                 </a:solidFill>
                 <a:latin typeface="Calibri"/>
               </a:rPr>
-              <a:t>6 / 24</a:t>
+              <a:t>6 / 25</a:t>
             </a:r>
           </a:p>
         </p:txBody>
@@ -27516,7 +28855,7 @@
                 </a:solidFill>
                 <a:latin typeface="Calibri"/>
               </a:rPr>
-              <a:t>S4  ·  7 / 24</a:t>
+              <a:t>S4  ·  7 / 25</a:t>
             </a:r>
           </a:p>
         </p:txBody>
@@ -28038,7 +29377,7 @@
                           </a:solidFill>
                           <a:latin typeface="Calibri"/>
                         </a:rPr>
-                        <a:t>Retail-Plus orders per member fell about a third against Retail-Core's 2.7 percent, on 22 members, and chance made a gap that large in none of 5,000 shuffles.</a:t>
+                        <a:t>Retail-Plus revenue per member fell from Rs 3,279 to Rs 2,169 on 22 members, against Retail-Core's Rs 110, and 135 of 5,000 shuffles made a fall that large.</a:t>
                       </a:r>
                     </a:p>
                   </a:txBody>
@@ -28570,7 +29909,7 @@
                 </a:solidFill>
                 <a:latin typeface="Calibri"/>
               </a:rPr>
-              <a:t>S5  ·  8 / 24</a:t>
+              <a:t>S5  ·  8 / 25</a:t>
             </a:r>
           </a:p>
         </p:txBody>
@@ -28965,7 +30304,7 @@
                           </a:solidFill>
                           <a:latin typeface="Calibri"/>
                         </a:rPr>
-                        <a:t>Holds: the measure, the comparison, the count and the chance test, in one sentence</a:t>
+                        <a:t>Holds: the measure, the comparison, the count and the chance test (0.027), in one sentence</a:t>
                       </a:r>
                     </a:p>
                   </a:txBody>
@@ -29688,7 +31027,7 @@
                 </a:solidFill>
                 <a:latin typeface="Calibri"/>
               </a:rPr>
-              <a:t>S6  ·  9 / 24</a:t>
+              <a:t>S6  ·  9 / 25</a:t>
             </a:r>
           </a:p>
         </p:txBody>

</xml_diff>

<commit_message>
Saturday's presentation-format deck names the US data and is rebuilt from its markdown
Dr Menon's slide said two cities fell in Q2, a clinic's no-show rate and the payment feed's
invoices; it now says two metros in Q3, a centre, and the posting system keying claims, with the
at-home collection offer. The Kalpa Retail example on the evidence slide keeps its rupees. The pptx
had not been rebuilt since the rubric moved to dollars, and is rebuilt now.

Co-Authored-By: Claude Opus 5.5 <noreply@anthropic.com>
Claude-Session: https://claude.ai/code/session_01P7zaoR4dQ5pzBFnsX549JQ
</commit_message>
<xml_diff>
--- a/content/W03/SAT/slides/C2_W03_SAT_presentation_format_STUDENT.pptx
+++ b/content/W03/SAT/slides/C2_W03_SAT_presentation_format_STUDENT.pptx
@@ -8047,7 +8047,7 @@
       </p:sp>
       <p:pic>
         <p:nvPicPr>
-          <p:cNvPr id="9" name="mermaid diagram" descr="17cc600c4d1c39fd.png"/>
+          <p:cNvPr id="9" name="mermaid diagram" descr="8cbfdf6ed9e5151c.png"/>
           <p:cNvPicPr>
             <a:picLocks noChangeAspect="1"/>
           </p:cNvPicPr>
@@ -9186,7 +9186,7 @@
       </p:sp>
       <p:pic>
         <p:nvPicPr>
-          <p:cNvPr id="9" name="mermaid diagram" descr="6cbc07735588a086.png"/>
+          <p:cNvPr id="9" name="mermaid diagram" descr="191e197cdcf9e59f.png"/>
           <p:cNvPicPr>
             <a:picLocks noChangeAspect="1"/>
           </p:cNvPicPr>
@@ -12463,7 +12463,7 @@
       </p:sp>
       <p:pic>
         <p:nvPicPr>
-          <p:cNvPr id="27" name="mermaid diagram" descr="c63136565dc4db6b.png"/>
+          <p:cNvPr id="27" name="mermaid diagram" descr="82a043bc9c560555.png"/>
           <p:cNvPicPr>
             <a:picLocks noChangeAspect="1"/>
           </p:cNvPicPr>
@@ -17682,7 +17682,7 @@
       </p:sp>
       <p:pic>
         <p:nvPicPr>
-          <p:cNvPr id="9" name="mermaid diagram" descr="60c46a3435eae6be.png"/>
+          <p:cNvPr id="9" name="mermaid diagram" descr="6a00f2eb8690a011.png"/>
           <p:cNvPicPr>
             <a:picLocks noChangeAspect="1"/>
           </p:cNvPicPr>
@@ -21904,14 +21904,53 @@
       </p:sp>
       <p:sp>
         <p:nvSpPr>
-          <p:cNvPr id="9" name="Rounded Rectangle 8"/>
+          <p:cNvPr id="9" name="TextBox 8"/>
+          <p:cNvSpPr txBox="1"/>
+          <p:nvPr/>
+        </p:nvSpPr>
+        <p:spPr>
+          <a:xfrm>
+            <a:off x="530352" y="1881632"/>
+            <a:ext cx="11130991" cy="409448"/>
+          </a:xfrm>
+          <a:prstGeom prst="rect">
+            <a:avLst/>
+          </a:prstGeom>
+          <a:noFill/>
+        </p:spPr>
+        <p:txBody>
+          <a:bodyPr wrap="square" anchor="t" lIns="0" rIns="0" tIns="0" bIns="0">
+            <a:spAutoFit/>
+          </a:bodyPr>
+          <a:lstStyle/>
+          <a:p>
+            <a:pPr>
+              <a:spcAft>
+                <a:spcPts val="500"/>
+              </a:spcAft>
+            </a:pPr>
+            <a:r>
+              <a:rPr sz="1100" b="0" i="0">
+                <a:solidFill>
+                  <a:srgbClr val="1A1440"/>
+                </a:solidFill>
+                <a:latin typeface="Calibri"/>
+              </a:rPr>
+              <a:t>&lt;!-- sync:rubric:W03/mini-project --&gt;</a:t>
+            </a:r>
+          </a:p>
+        </p:txBody>
+      </p:sp>
+      <p:sp>
+        <p:nvSpPr>
+          <p:cNvPr id="10" name="Rounded Rectangle 9"/>
           <p:cNvSpPr/>
           <p:nvPr/>
         </p:nvSpPr>
         <p:spPr>
           <a:xfrm>
-            <a:off x="530352" y="1956816"/>
-            <a:ext cx="11130991" cy="736600"/>
+            <a:off x="530352" y="2419096"/>
+            <a:ext cx="11130991" cy="629920"/>
           </a:xfrm>
           <a:prstGeom prst="roundRect">
             <a:avLst>
@@ -21952,14 +21991,14 @@
       </p:sp>
       <p:sp>
         <p:nvSpPr>
-          <p:cNvPr id="10" name="Rounded Rectangle 9"/>
+          <p:cNvPr id="11" name="Rounded Rectangle 10"/>
           <p:cNvSpPr/>
           <p:nvPr/>
         </p:nvSpPr>
         <p:spPr>
           <a:xfrm>
-            <a:off x="676656" y="2084832"/>
-            <a:ext cx="45720" cy="480568"/>
+            <a:off x="676656" y="2547112"/>
+            <a:ext cx="45720" cy="373888"/>
           </a:xfrm>
           <a:prstGeom prst="roundRect">
             <a:avLst>
@@ -21998,14 +22037,14 @@
       </p:sp>
       <p:sp>
         <p:nvSpPr>
-          <p:cNvPr id="11" name="TextBox 10"/>
-          <p:cNvSpPr txBox="1"/>
-          <p:nvPr/>
-        </p:nvSpPr>
-        <p:spPr>
-          <a:xfrm>
-            <a:off x="877824" y="2075688"/>
-            <a:ext cx="10564063" cy="553720"/>
+          <p:cNvPr id="12" name="TextBox 11"/>
+          <p:cNvSpPr txBox="1"/>
+          <p:nvPr/>
+        </p:nvSpPr>
+        <p:spPr>
+          <a:xfrm>
+            <a:off x="877824" y="2537968"/>
+            <a:ext cx="10564063" cy="447040"/>
           </a:xfrm>
           <a:prstGeom prst="rect">
             <a:avLst/>
@@ -22019,7 +22058,7 @@
           <a:lstStyle/>
           <a:p>
             <a:r>
-              <a:rPr sz="1300" b="1">
+              <a:rPr sz="1000" b="1">
                 <a:solidFill>
                   <a:srgbClr val="5B3FD6"/>
                 </a:solidFill>
@@ -22028,7 +22067,7 @@
               <a:t>Mini project, 40 marks. </a:t>
             </a:r>
             <a:r>
-              <a:rPr sz="1300" b="0" i="0">
+              <a:rPr sz="1000" b="0" i="0">
                 <a:solidFill>
                   <a:srgbClr val="1A1440"/>
                 </a:solidFill>
@@ -22041,15 +22080,15 @@
       </p:sp>
       <p:graphicFrame>
         <p:nvGraphicFramePr>
-          <p:cNvPr id="12" name="Table 11"/>
+          <p:cNvPr id="13" name="Table 12"/>
           <p:cNvGraphicFramePr>
             <a:graphicFrameLocks noGrp="1"/>
           </p:cNvGraphicFramePr>
           <p:nvPr/>
         </p:nvGraphicFramePr>
         <p:xfrm>
-          <a:off x="530352" y="2858008"/>
-          <a:ext cx="11130990" cy="2840736"/>
+          <a:off x="530352" y="3213608"/>
+          <a:ext cx="11130991" cy="2121408"/>
         </p:xfrm>
         <a:graphic>
           <a:graphicData uri="http://schemas.openxmlformats.org/drawingml/2006/table">
@@ -22058,18 +22097,18 @@
                 <a:tableStyleId>{2D5ABB26-0587-4C30-8999-92F81FD0307C}</a:tableStyleId>
               </a:tblPr>
               <a:tblGrid>
-                <a:gridCol w="2886034"/>
+                <a:gridCol w="2388579"/>
                 <a:gridCol w="914400"/>
-                <a:gridCol w="7330556"/>
+                <a:gridCol w="7828012"/>
               </a:tblGrid>
-              <a:tr h="335280">
+              <a:tr h="310896">
                 <a:tc>
                   <a:txBody>
                     <a:bodyPr/>
                     <a:lstStyle/>
                     <a:p>
                       <a:r>
-                        <a:rPr sz="1250" b="1" i="0">
+                        <a:rPr sz="950" b="1" i="0">
                           <a:solidFill>
                             <a:srgbClr val="FFFFFF"/>
                           </a:solidFill>
@@ -22091,7 +22130,7 @@
                     <a:lstStyle/>
                     <a:p>
                       <a:r>
-                        <a:rPr sz="1250" b="1" i="0">
+                        <a:rPr sz="950" b="1" i="0">
                           <a:solidFill>
                             <a:srgbClr val="FFFFFF"/>
                           </a:solidFill>
@@ -22113,7 +22152,7 @@
                     <a:lstStyle/>
                     <a:p>
                       <a:r>
-                        <a:rPr sz="1250" b="1" i="0">
+                        <a:rPr sz="950" b="1" i="0">
                           <a:solidFill>
                             <a:srgbClr val="FFFFFF"/>
                           </a:solidFill>
@@ -22130,14 +22169,14 @@
                   </a:tcPr>
                 </a:tc>
               </a:tr>
-              <a:tr h="542544">
+              <a:tr h="310896">
                 <a:tc>
                   <a:txBody>
                     <a:bodyPr/>
                     <a:lstStyle/>
                     <a:p>
                       <a:r>
-                        <a:rPr sz="1200" b="0" i="0">
+                        <a:rPr sz="900" b="0" i="0">
                           <a:solidFill>
                             <a:srgbClr val="1A1440"/>
                           </a:solidFill>
@@ -22159,7 +22198,7 @@
                     <a:lstStyle/>
                     <a:p>
                       <a:r>
-                        <a:rPr sz="1200" b="0" i="0">
+                        <a:rPr sz="900" b="0" i="0">
                           <a:solidFill>
                             <a:srgbClr val="1A1440"/>
                           </a:solidFill>
@@ -22181,7 +22220,7 @@
                     <a:lstStyle/>
                     <a:p>
                       <a:r>
-                        <a:rPr sz="1200" b="0" i="0">
+                        <a:rPr sz="900" b="0" i="0">
                           <a:solidFill>
                             <a:srgbClr val="1A1440"/>
                           </a:solidFill>
@@ -22198,14 +22237,14 @@
                   </a:tcPr>
                 </a:tc>
               </a:tr>
-              <a:tr h="542544">
+              <a:tr h="438912">
                 <a:tc>
                   <a:txBody>
                     <a:bodyPr/>
                     <a:lstStyle/>
                     <a:p>
                       <a:r>
-                        <a:rPr sz="1200" b="0" i="0">
+                        <a:rPr sz="900" b="0" i="0">
                           <a:solidFill>
                             <a:srgbClr val="1A1440"/>
                           </a:solidFill>
@@ -22227,7 +22266,7 @@
                     <a:lstStyle/>
                     <a:p>
                       <a:r>
-                        <a:rPr sz="1200" b="0" i="0">
+                        <a:rPr sz="900" b="0" i="0">
                           <a:solidFill>
                             <a:srgbClr val="1A1440"/>
                           </a:solidFill>
@@ -22249,13 +22288,13 @@
                     <a:lstStyle/>
                     <a:p>
                       <a:r>
-                        <a:rPr sz="1200" b="0" i="0">
+                        <a:rPr sz="900" b="0" i="0">
                           <a:solidFill>
                             <a:srgbClr val="1A1440"/>
                           </a:solidFill>
                           <a:latin typeface="Calibri"/>
                         </a:rPr>
-                        <a:t>The data is profiled before it is touched, every cleaning call is in the decisions log with its reason, and counts and rupees reconcile across files.</a:t>
+                        <a:t>The data is profiled before it is touched, every cleaning call is in the decisions log with its reason, and counts and dollars reconcile across files.</a:t>
                       </a:r>
                     </a:p>
                   </a:txBody>
@@ -22266,14 +22305,14 @@
                   </a:tcPr>
                 </a:tc>
               </a:tr>
-              <a:tr h="542544">
+              <a:tr h="438912">
                 <a:tc>
                   <a:txBody>
                     <a:bodyPr/>
                     <a:lstStyle/>
                     <a:p>
                       <a:r>
-                        <a:rPr sz="1200" b="0" i="0">
+                        <a:rPr sz="900" b="0" i="0">
                           <a:solidFill>
                             <a:srgbClr val="1A1440"/>
                           </a:solidFill>
@@ -22295,7 +22334,7 @@
                     <a:lstStyle/>
                     <a:p>
                       <a:r>
-                        <a:rPr sz="1200" b="0" i="0">
+                        <a:rPr sz="900" b="0" i="0">
                           <a:solidFill>
                             <a:srgbClr val="1A1440"/>
                           </a:solidFill>
@@ -22317,7 +22356,7 @@
                     <a:lstStyle/>
                     <a:p>
                       <a:r>
-                        <a:rPr sz="1200" b="0" i="0">
+                        <a:rPr sz="900" b="0" i="0">
                           <a:solidFill>
                             <a:srgbClr val="1A1440"/>
                           </a:solidFill>
@@ -22334,14 +22373,14 @@
                   </a:tcPr>
                 </a:tc>
               </a:tr>
-              <a:tr h="542544">
+              <a:tr h="310896">
                 <a:tc>
                   <a:txBody>
                     <a:bodyPr/>
                     <a:lstStyle/>
                     <a:p>
                       <a:r>
-                        <a:rPr sz="1200" b="0" i="0">
+                        <a:rPr sz="900" b="0" i="0">
                           <a:solidFill>
                             <a:srgbClr val="1A1440"/>
                           </a:solidFill>
@@ -22363,7 +22402,7 @@
                     <a:lstStyle/>
                     <a:p>
                       <a:r>
-                        <a:rPr sz="1200" b="0" i="0">
+                        <a:rPr sz="900" b="0" i="0">
                           <a:solidFill>
                             <a:srgbClr val="1A1440"/>
                           </a:solidFill>
@@ -22385,7 +22424,7 @@
                     <a:lstStyle/>
                     <a:p>
                       <a:r>
-                        <a:rPr sz="1200" b="0" i="0">
+                        <a:rPr sz="900" b="0" i="0">
                           <a:solidFill>
                             <a:srgbClr val="1A1440"/>
                           </a:solidFill>
@@ -22402,14 +22441,14 @@
                   </a:tcPr>
                 </a:tc>
               </a:tr>
-              <a:tr h="335280">
+              <a:tr h="310896">
                 <a:tc>
                   <a:txBody>
                     <a:bodyPr/>
                     <a:lstStyle/>
                     <a:p>
                       <a:r>
-                        <a:rPr sz="1200" b="0" i="0">
+                        <a:rPr sz="900" b="0" i="0">
                           <a:solidFill>
                             <a:srgbClr val="1A1440"/>
                           </a:solidFill>
@@ -22431,7 +22470,7 @@
                     <a:lstStyle/>
                     <a:p>
                       <a:r>
-                        <a:rPr sz="1200" b="0" i="0">
+                        <a:rPr sz="900" b="0" i="0">
                           <a:solidFill>
                             <a:srgbClr val="1A1440"/>
                           </a:solidFill>
@@ -22453,7 +22492,7 @@
                     <a:lstStyle/>
                     <a:p>
                       <a:r>
-                        <a:rPr sz="1200" b="0" i="0">
+                        <a:rPr sz="900" b="0" i="0">
                           <a:solidFill>
                             <a:srgbClr val="1A1440"/>
                           </a:solidFill>
@@ -22476,7 +22515,46 @@
       </p:graphicFrame>
       <p:sp>
         <p:nvSpPr>
-          <p:cNvPr id="13" name="Oval 12"/>
+          <p:cNvPr id="14" name="TextBox 13"/>
+          <p:cNvSpPr txBox="1"/>
+          <p:nvPr/>
+        </p:nvSpPr>
+        <p:spPr>
+          <a:xfrm>
+            <a:off x="530352" y="5591048"/>
+            <a:ext cx="11130991" cy="409448"/>
+          </a:xfrm>
+          <a:prstGeom prst="rect">
+            <a:avLst/>
+          </a:prstGeom>
+          <a:noFill/>
+        </p:spPr>
+        <p:txBody>
+          <a:bodyPr wrap="square" anchor="t" lIns="0" rIns="0" tIns="0" bIns="0">
+            <a:spAutoFit/>
+          </a:bodyPr>
+          <a:lstStyle/>
+          <a:p>
+            <a:pPr>
+              <a:spcAft>
+                <a:spcPts val="500"/>
+              </a:spcAft>
+            </a:pPr>
+            <a:r>
+              <a:rPr sz="1100" b="0" i="0">
+                <a:solidFill>
+                  <a:srgbClr val="1A1440"/>
+                </a:solidFill>
+                <a:latin typeface="Calibri"/>
+              </a:rPr>
+              <a:t>&lt;!-- /sync:rubric:W03/mini-project --&gt;</a:t>
+            </a:r>
+          </a:p>
+        </p:txBody>
+      </p:sp>
+      <p:sp>
+        <p:nvSpPr>
+          <p:cNvPr id="15" name="Oval 14"/>
           <p:cNvSpPr/>
           <p:nvPr/>
         </p:nvSpPr>
@@ -22520,7 +22598,7 @@
       </p:sp>
       <p:sp>
         <p:nvSpPr>
-          <p:cNvPr id="14" name="TextBox 13"/>
+          <p:cNvPr id="16" name="TextBox 15"/>
           <p:cNvSpPr txBox="1"/>
           <p:nvPr/>
         </p:nvSpPr>
@@ -22555,7 +22633,7 @@
       </p:sp>
       <p:sp>
         <p:nvSpPr>
-          <p:cNvPr id="15" name="Oval 14"/>
+          <p:cNvPr id="17" name="Oval 16"/>
           <p:cNvSpPr/>
           <p:nvPr/>
         </p:nvSpPr>
@@ -22599,7 +22677,7 @@
       </p:sp>
       <p:sp>
         <p:nvSpPr>
-          <p:cNvPr id="16" name="TextBox 15"/>
+          <p:cNvPr id="18" name="TextBox 17"/>
           <p:cNvSpPr txBox="1"/>
           <p:nvPr/>
         </p:nvSpPr>
@@ -22634,7 +22712,7 @@
       </p:sp>
       <p:sp>
         <p:nvSpPr>
-          <p:cNvPr id="17" name="Oval 16"/>
+          <p:cNvPr id="19" name="Oval 18"/>
           <p:cNvSpPr/>
           <p:nvPr/>
         </p:nvSpPr>
@@ -22678,7 +22756,7 @@
       </p:sp>
       <p:sp>
         <p:nvSpPr>
-          <p:cNvPr id="18" name="TextBox 17"/>
+          <p:cNvPr id="20" name="TextBox 19"/>
           <p:cNvSpPr txBox="1"/>
           <p:nvPr/>
         </p:nvSpPr>
@@ -22713,7 +22791,7 @@
       </p:sp>
       <p:sp>
         <p:nvSpPr>
-          <p:cNvPr id="19" name="Oval 18"/>
+          <p:cNvPr id="21" name="Oval 20"/>
           <p:cNvSpPr/>
           <p:nvPr/>
         </p:nvSpPr>
@@ -22757,7 +22835,7 @@
       </p:sp>
       <p:sp>
         <p:nvSpPr>
-          <p:cNvPr id="20" name="TextBox 19"/>
+          <p:cNvPr id="22" name="TextBox 21"/>
           <p:cNvSpPr txBox="1"/>
           <p:nvPr/>
         </p:nvSpPr>
@@ -22792,7 +22870,7 @@
       </p:sp>
       <p:sp>
         <p:nvSpPr>
-          <p:cNvPr id="21" name="Oval 20"/>
+          <p:cNvPr id="23" name="Oval 22"/>
           <p:cNvSpPr/>
           <p:nvPr/>
         </p:nvSpPr>
@@ -22836,7 +22914,7 @@
       </p:sp>
       <p:sp>
         <p:nvSpPr>
-          <p:cNvPr id="22" name="TextBox 21"/>
+          <p:cNvPr id="24" name="TextBox 23"/>
           <p:cNvSpPr txBox="1"/>
           <p:nvPr/>
         </p:nvSpPr>
@@ -22871,7 +22949,7 @@
       </p:sp>
       <p:sp>
         <p:nvSpPr>
-          <p:cNvPr id="23" name="TextBox 22"/>
+          <p:cNvPr id="25" name="TextBox 24"/>
           <p:cNvSpPr txBox="1"/>
           <p:nvPr/>
         </p:nvSpPr>
@@ -24448,7 +24526,7 @@
                 </a:solidFill>
                 <a:latin typeface="Georgia"/>
               </a:rPr>
-              <a:t>2 cities</a:t>
+              <a:t>2 metros</a:t>
             </a:r>
           </a:p>
         </p:txBody>
@@ -24518,7 +24596,7 @@
                 </a:solidFill>
                 <a:latin typeface="Calibri"/>
               </a:rPr>
-              <a:t>in Q2, per the booking data</a:t>
+              <a:t>in Q3, per the booking data</a:t>
             </a:r>
           </a:p>
         </p:txBody>
@@ -24667,7 +24745,7 @@
                 </a:solidFill>
                 <a:latin typeface="Calibri"/>
               </a:rPr>
-              <a:t>free home collection, per marketing</a:t>
+              <a:t>free at-home collection, per marketing</a:t>
             </a:r>
           </a:p>
         </p:txBody>
@@ -24746,7 +24824,7 @@
                 </a:solidFill>
                 <a:latin typeface="Georgia"/>
               </a:rPr>
-              <a:t>1 clinic</a:t>
+              <a:t>1 centre</a:t>
             </a:r>
           </a:p>
         </p:txBody>
@@ -24816,7 +24894,7 @@
                 </a:solidFill>
                 <a:latin typeface="Calibri"/>
               </a:rPr>
-              <a:t>per the clinics' operations head</a:t>
+              <a:t>per the centres' operations head</a:t>
             </a:r>
           </a:p>
         </p:txBody>
@@ -24997,7 +25075,7 @@
                 </a:solidFill>
                 <a:latin typeface="Calibri"/>
               </a:rPr>
-              <a:t>Her data team adds two things it knows: two cities changed booking systems in Q2, and the payment feed keys invoices in its own format. Invoices and collections disagree, says the finance head.</a:t>
+              <a:t>Her data team adds two things it knows: two metros changed booking systems in Q3, and the posting system keys claims in its own format. Claims and collections disagree, says the finance head.</a:t>
             </a:r>
           </a:p>
         </p:txBody>
@@ -25675,7 +25753,7 @@
       </p:sp>
       <p:pic>
         <p:nvPicPr>
-          <p:cNvPr id="9" name="mermaid diagram" descr="3d371e6dc20be8ea.png"/>
+          <p:cNvPr id="9" name="mermaid diagram" descr="75da118c6c09b653.png"/>
           <p:cNvPicPr>
             <a:picLocks noChangeAspect="1"/>
           </p:cNvPicPr>
@@ -27494,7 +27572,7 @@
       </p:sp>
       <p:pic>
         <p:nvPicPr>
-          <p:cNvPr id="9" name="mermaid diagram" descr="7fed46ddb74270e8.png"/>
+          <p:cNvPr id="9" name="mermaid diagram" descr="6183dc27bdd6055b.png"/>
           <p:cNvPicPr>
             <a:picLocks noChangeAspect="1"/>
           </p:cNvPicPr>

</xml_diff>

<commit_message>
build_deck drops whole-line HTML comments outside code fences, so a sync block's markers never print on a slide
Build 1 Saturday's presentation-format deck printed both rubric sync markers on slide 25; it is
rebuilt, and its only text change is the two markers gone. Reported by the Build 1 Monday session,
which had worked around it with a stripped copy.

Co-Authored-By: Claude Opus 5.5 <noreply@anthropic.com>
Claude-Session: https://claude.ai/code/session_01P7zaoR4dQ5pzBFnsX549JQ
</commit_message>
<xml_diff>
--- a/content/W03/SAT/slides/C2_W03_SAT_presentation_format_STUDENT.pptx
+++ b/content/W03/SAT/slides/C2_W03_SAT_presentation_format_STUDENT.pptx
@@ -8047,7 +8047,7 @@
       </p:sp>
       <p:pic>
         <p:nvPicPr>
-          <p:cNvPr id="9" name="mermaid diagram" descr="8cbfdf6ed9e5151c.png"/>
+          <p:cNvPr id="9" name="mermaid diagram" descr="9cc27da138356b74.png"/>
           <p:cNvPicPr>
             <a:picLocks noChangeAspect="1"/>
           </p:cNvPicPr>
@@ -9186,7 +9186,7 @@
       </p:sp>
       <p:pic>
         <p:nvPicPr>
-          <p:cNvPr id="9" name="mermaid diagram" descr="191e197cdcf9e59f.png"/>
+          <p:cNvPr id="9" name="mermaid diagram" descr="4ced1e7efd73d80d.png"/>
           <p:cNvPicPr>
             <a:picLocks noChangeAspect="1"/>
           </p:cNvPicPr>
@@ -12463,7 +12463,7 @@
       </p:sp>
       <p:pic>
         <p:nvPicPr>
-          <p:cNvPr id="27" name="mermaid diagram" descr="82a043bc9c560555.png"/>
+          <p:cNvPr id="27" name="mermaid diagram" descr="9250a54a9cf90071.png"/>
           <p:cNvPicPr>
             <a:picLocks noChangeAspect="1"/>
           </p:cNvPicPr>
@@ -17682,7 +17682,7 @@
       </p:sp>
       <p:pic>
         <p:nvPicPr>
-          <p:cNvPr id="9" name="mermaid diagram" descr="6a00f2eb8690a011.png"/>
+          <p:cNvPr id="9" name="mermaid diagram" descr="70d0637ba1235123.png"/>
           <p:cNvPicPr>
             <a:picLocks noChangeAspect="1"/>
           </p:cNvPicPr>
@@ -21904,53 +21904,14 @@
       </p:sp>
       <p:sp>
         <p:nvSpPr>
-          <p:cNvPr id="9" name="TextBox 8"/>
-          <p:cNvSpPr txBox="1"/>
-          <p:nvPr/>
-        </p:nvSpPr>
-        <p:spPr>
-          <a:xfrm>
-            <a:off x="530352" y="1881632"/>
-            <a:ext cx="11130991" cy="409448"/>
-          </a:xfrm>
-          <a:prstGeom prst="rect">
-            <a:avLst/>
-          </a:prstGeom>
-          <a:noFill/>
-        </p:spPr>
-        <p:txBody>
-          <a:bodyPr wrap="square" anchor="t" lIns="0" rIns="0" tIns="0" bIns="0">
-            <a:spAutoFit/>
-          </a:bodyPr>
-          <a:lstStyle/>
-          <a:p>
-            <a:pPr>
-              <a:spcAft>
-                <a:spcPts val="500"/>
-              </a:spcAft>
-            </a:pPr>
-            <a:r>
-              <a:rPr sz="1100" b="0" i="0">
-                <a:solidFill>
-                  <a:srgbClr val="1A1440"/>
-                </a:solidFill>
-                <a:latin typeface="Calibri"/>
-              </a:rPr>
-              <a:t>&lt;!-- sync:rubric:W03/mini-project --&gt;</a:t>
-            </a:r>
-          </a:p>
-        </p:txBody>
-      </p:sp>
-      <p:sp>
-        <p:nvSpPr>
-          <p:cNvPr id="10" name="Rounded Rectangle 9"/>
+          <p:cNvPr id="9" name="Rounded Rectangle 8"/>
           <p:cNvSpPr/>
           <p:nvPr/>
         </p:nvSpPr>
         <p:spPr>
           <a:xfrm>
-            <a:off x="530352" y="2419096"/>
-            <a:ext cx="11130991" cy="629920"/>
+            <a:off x="530352" y="1956816"/>
+            <a:ext cx="11130991" cy="736600"/>
           </a:xfrm>
           <a:prstGeom prst="roundRect">
             <a:avLst>
@@ -21991,14 +21952,14 @@
       </p:sp>
       <p:sp>
         <p:nvSpPr>
-          <p:cNvPr id="11" name="Rounded Rectangle 10"/>
+          <p:cNvPr id="10" name="Rounded Rectangle 9"/>
           <p:cNvSpPr/>
           <p:nvPr/>
         </p:nvSpPr>
         <p:spPr>
           <a:xfrm>
-            <a:off x="676656" y="2547112"/>
-            <a:ext cx="45720" cy="373888"/>
+            <a:off x="676656" y="2084832"/>
+            <a:ext cx="45720" cy="480568"/>
           </a:xfrm>
           <a:prstGeom prst="roundRect">
             <a:avLst>
@@ -22037,14 +21998,14 @@
       </p:sp>
       <p:sp>
         <p:nvSpPr>
-          <p:cNvPr id="12" name="TextBox 11"/>
-          <p:cNvSpPr txBox="1"/>
-          <p:nvPr/>
-        </p:nvSpPr>
-        <p:spPr>
-          <a:xfrm>
-            <a:off x="877824" y="2537968"/>
-            <a:ext cx="10564063" cy="447040"/>
+          <p:cNvPr id="11" name="TextBox 10"/>
+          <p:cNvSpPr txBox="1"/>
+          <p:nvPr/>
+        </p:nvSpPr>
+        <p:spPr>
+          <a:xfrm>
+            <a:off x="877824" y="2075688"/>
+            <a:ext cx="10564063" cy="553720"/>
           </a:xfrm>
           <a:prstGeom prst="rect">
             <a:avLst/>
@@ -22058,7 +22019,7 @@
           <a:lstStyle/>
           <a:p>
             <a:r>
-              <a:rPr sz="1000" b="1">
+              <a:rPr sz="1300" b="1">
                 <a:solidFill>
                   <a:srgbClr val="5B3FD6"/>
                 </a:solidFill>
@@ -22067,7 +22028,7 @@
               <a:t>Mini project, 40 marks. </a:t>
             </a:r>
             <a:r>
-              <a:rPr sz="1000" b="0" i="0">
+              <a:rPr sz="1300" b="0" i="0">
                 <a:solidFill>
                   <a:srgbClr val="1A1440"/>
                 </a:solidFill>
@@ -22080,15 +22041,15 @@
       </p:sp>
       <p:graphicFrame>
         <p:nvGraphicFramePr>
-          <p:cNvPr id="13" name="Table 12"/>
+          <p:cNvPr id="12" name="Table 11"/>
           <p:cNvGraphicFramePr>
             <a:graphicFrameLocks noGrp="1"/>
           </p:cNvGraphicFramePr>
           <p:nvPr/>
         </p:nvGraphicFramePr>
         <p:xfrm>
-          <a:off x="530352" y="3213608"/>
-          <a:ext cx="11130991" cy="2121408"/>
+          <a:off x="530352" y="2858008"/>
+          <a:ext cx="11130990" cy="2840736"/>
         </p:xfrm>
         <a:graphic>
           <a:graphicData uri="http://schemas.openxmlformats.org/drawingml/2006/table">
@@ -22097,18 +22058,18 @@
                 <a:tableStyleId>{2D5ABB26-0587-4C30-8999-92F81FD0307C}</a:tableStyleId>
               </a:tblPr>
               <a:tblGrid>
-                <a:gridCol w="2388579"/>
+                <a:gridCol w="2886034"/>
                 <a:gridCol w="914400"/>
-                <a:gridCol w="7828012"/>
+                <a:gridCol w="7330556"/>
               </a:tblGrid>
-              <a:tr h="310896">
+              <a:tr h="335280">
                 <a:tc>
                   <a:txBody>
                     <a:bodyPr/>
                     <a:lstStyle/>
                     <a:p>
                       <a:r>
-                        <a:rPr sz="950" b="1" i="0">
+                        <a:rPr sz="1250" b="1" i="0">
                           <a:solidFill>
                             <a:srgbClr val="FFFFFF"/>
                           </a:solidFill>
@@ -22130,7 +22091,7 @@
                     <a:lstStyle/>
                     <a:p>
                       <a:r>
-                        <a:rPr sz="950" b="1" i="0">
+                        <a:rPr sz="1250" b="1" i="0">
                           <a:solidFill>
                             <a:srgbClr val="FFFFFF"/>
                           </a:solidFill>
@@ -22152,7 +22113,7 @@
                     <a:lstStyle/>
                     <a:p>
                       <a:r>
-                        <a:rPr sz="950" b="1" i="0">
+                        <a:rPr sz="1250" b="1" i="0">
                           <a:solidFill>
                             <a:srgbClr val="FFFFFF"/>
                           </a:solidFill>
@@ -22169,14 +22130,14 @@
                   </a:tcPr>
                 </a:tc>
               </a:tr>
-              <a:tr h="310896">
+              <a:tr h="542544">
                 <a:tc>
                   <a:txBody>
                     <a:bodyPr/>
                     <a:lstStyle/>
                     <a:p>
                       <a:r>
-                        <a:rPr sz="900" b="0" i="0">
+                        <a:rPr sz="1200" b="0" i="0">
                           <a:solidFill>
                             <a:srgbClr val="1A1440"/>
                           </a:solidFill>
@@ -22198,7 +22159,7 @@
                     <a:lstStyle/>
                     <a:p>
                       <a:r>
-                        <a:rPr sz="900" b="0" i="0">
+                        <a:rPr sz="1200" b="0" i="0">
                           <a:solidFill>
                             <a:srgbClr val="1A1440"/>
                           </a:solidFill>
@@ -22220,7 +22181,7 @@
                     <a:lstStyle/>
                     <a:p>
                       <a:r>
-                        <a:rPr sz="900" b="0" i="0">
+                        <a:rPr sz="1200" b="0" i="0">
                           <a:solidFill>
                             <a:srgbClr val="1A1440"/>
                           </a:solidFill>
@@ -22237,14 +22198,14 @@
                   </a:tcPr>
                 </a:tc>
               </a:tr>
-              <a:tr h="438912">
+              <a:tr h="542544">
                 <a:tc>
                   <a:txBody>
                     <a:bodyPr/>
                     <a:lstStyle/>
                     <a:p>
                       <a:r>
-                        <a:rPr sz="900" b="0" i="0">
+                        <a:rPr sz="1200" b="0" i="0">
                           <a:solidFill>
                             <a:srgbClr val="1A1440"/>
                           </a:solidFill>
@@ -22266,7 +22227,7 @@
                     <a:lstStyle/>
                     <a:p>
                       <a:r>
-                        <a:rPr sz="900" b="0" i="0">
+                        <a:rPr sz="1200" b="0" i="0">
                           <a:solidFill>
                             <a:srgbClr val="1A1440"/>
                           </a:solidFill>
@@ -22288,7 +22249,7 @@
                     <a:lstStyle/>
                     <a:p>
                       <a:r>
-                        <a:rPr sz="900" b="0" i="0">
+                        <a:rPr sz="1200" b="0" i="0">
                           <a:solidFill>
                             <a:srgbClr val="1A1440"/>
                           </a:solidFill>
@@ -22305,14 +22266,14 @@
                   </a:tcPr>
                 </a:tc>
               </a:tr>
-              <a:tr h="438912">
+              <a:tr h="542544">
                 <a:tc>
                   <a:txBody>
                     <a:bodyPr/>
                     <a:lstStyle/>
                     <a:p>
                       <a:r>
-                        <a:rPr sz="900" b="0" i="0">
+                        <a:rPr sz="1200" b="0" i="0">
                           <a:solidFill>
                             <a:srgbClr val="1A1440"/>
                           </a:solidFill>
@@ -22334,7 +22295,7 @@
                     <a:lstStyle/>
                     <a:p>
                       <a:r>
-                        <a:rPr sz="900" b="0" i="0">
+                        <a:rPr sz="1200" b="0" i="0">
                           <a:solidFill>
                             <a:srgbClr val="1A1440"/>
                           </a:solidFill>
@@ -22356,7 +22317,7 @@
                     <a:lstStyle/>
                     <a:p>
                       <a:r>
-                        <a:rPr sz="900" b="0" i="0">
+                        <a:rPr sz="1200" b="0" i="0">
                           <a:solidFill>
                             <a:srgbClr val="1A1440"/>
                           </a:solidFill>
@@ -22373,14 +22334,14 @@
                   </a:tcPr>
                 </a:tc>
               </a:tr>
-              <a:tr h="310896">
+              <a:tr h="542544">
                 <a:tc>
                   <a:txBody>
                     <a:bodyPr/>
                     <a:lstStyle/>
                     <a:p>
                       <a:r>
-                        <a:rPr sz="900" b="0" i="0">
+                        <a:rPr sz="1200" b="0" i="0">
                           <a:solidFill>
                             <a:srgbClr val="1A1440"/>
                           </a:solidFill>
@@ -22402,7 +22363,7 @@
                     <a:lstStyle/>
                     <a:p>
                       <a:r>
-                        <a:rPr sz="900" b="0" i="0">
+                        <a:rPr sz="1200" b="0" i="0">
                           <a:solidFill>
                             <a:srgbClr val="1A1440"/>
                           </a:solidFill>
@@ -22424,7 +22385,7 @@
                     <a:lstStyle/>
                     <a:p>
                       <a:r>
-                        <a:rPr sz="900" b="0" i="0">
+                        <a:rPr sz="1200" b="0" i="0">
                           <a:solidFill>
                             <a:srgbClr val="1A1440"/>
                           </a:solidFill>
@@ -22441,14 +22402,14 @@
                   </a:tcPr>
                 </a:tc>
               </a:tr>
-              <a:tr h="310896">
+              <a:tr h="335280">
                 <a:tc>
                   <a:txBody>
                     <a:bodyPr/>
                     <a:lstStyle/>
                     <a:p>
                       <a:r>
-                        <a:rPr sz="900" b="0" i="0">
+                        <a:rPr sz="1200" b="0" i="0">
                           <a:solidFill>
                             <a:srgbClr val="1A1440"/>
                           </a:solidFill>
@@ -22470,7 +22431,7 @@
                     <a:lstStyle/>
                     <a:p>
                       <a:r>
-                        <a:rPr sz="900" b="0" i="0">
+                        <a:rPr sz="1200" b="0" i="0">
                           <a:solidFill>
                             <a:srgbClr val="1A1440"/>
                           </a:solidFill>
@@ -22492,7 +22453,7 @@
                     <a:lstStyle/>
                     <a:p>
                       <a:r>
-                        <a:rPr sz="900" b="0" i="0">
+                        <a:rPr sz="1200" b="0" i="0">
                           <a:solidFill>
                             <a:srgbClr val="1A1440"/>
                           </a:solidFill>
@@ -22515,46 +22476,7 @@
       </p:graphicFrame>
       <p:sp>
         <p:nvSpPr>
-          <p:cNvPr id="14" name="TextBox 13"/>
-          <p:cNvSpPr txBox="1"/>
-          <p:nvPr/>
-        </p:nvSpPr>
-        <p:spPr>
-          <a:xfrm>
-            <a:off x="530352" y="5591048"/>
-            <a:ext cx="11130991" cy="409448"/>
-          </a:xfrm>
-          <a:prstGeom prst="rect">
-            <a:avLst/>
-          </a:prstGeom>
-          <a:noFill/>
-        </p:spPr>
-        <p:txBody>
-          <a:bodyPr wrap="square" anchor="t" lIns="0" rIns="0" tIns="0" bIns="0">
-            <a:spAutoFit/>
-          </a:bodyPr>
-          <a:lstStyle/>
-          <a:p>
-            <a:pPr>
-              <a:spcAft>
-                <a:spcPts val="500"/>
-              </a:spcAft>
-            </a:pPr>
-            <a:r>
-              <a:rPr sz="1100" b="0" i="0">
-                <a:solidFill>
-                  <a:srgbClr val="1A1440"/>
-                </a:solidFill>
-                <a:latin typeface="Calibri"/>
-              </a:rPr>
-              <a:t>&lt;!-- /sync:rubric:W03/mini-project --&gt;</a:t>
-            </a:r>
-          </a:p>
-        </p:txBody>
-      </p:sp>
-      <p:sp>
-        <p:nvSpPr>
-          <p:cNvPr id="15" name="Oval 14"/>
+          <p:cNvPr id="13" name="Oval 12"/>
           <p:cNvSpPr/>
           <p:nvPr/>
         </p:nvSpPr>
@@ -22598,7 +22520,7 @@
       </p:sp>
       <p:sp>
         <p:nvSpPr>
-          <p:cNvPr id="16" name="TextBox 15"/>
+          <p:cNvPr id="14" name="TextBox 13"/>
           <p:cNvSpPr txBox="1"/>
           <p:nvPr/>
         </p:nvSpPr>
@@ -22633,7 +22555,7 @@
       </p:sp>
       <p:sp>
         <p:nvSpPr>
-          <p:cNvPr id="17" name="Oval 16"/>
+          <p:cNvPr id="15" name="Oval 14"/>
           <p:cNvSpPr/>
           <p:nvPr/>
         </p:nvSpPr>
@@ -22677,7 +22599,7 @@
       </p:sp>
       <p:sp>
         <p:nvSpPr>
-          <p:cNvPr id="18" name="TextBox 17"/>
+          <p:cNvPr id="16" name="TextBox 15"/>
           <p:cNvSpPr txBox="1"/>
           <p:nvPr/>
         </p:nvSpPr>
@@ -22712,7 +22634,7 @@
       </p:sp>
       <p:sp>
         <p:nvSpPr>
-          <p:cNvPr id="19" name="Oval 18"/>
+          <p:cNvPr id="17" name="Oval 16"/>
           <p:cNvSpPr/>
           <p:nvPr/>
         </p:nvSpPr>
@@ -22756,7 +22678,7 @@
       </p:sp>
       <p:sp>
         <p:nvSpPr>
-          <p:cNvPr id="20" name="TextBox 19"/>
+          <p:cNvPr id="18" name="TextBox 17"/>
           <p:cNvSpPr txBox="1"/>
           <p:nvPr/>
         </p:nvSpPr>
@@ -22791,7 +22713,7 @@
       </p:sp>
       <p:sp>
         <p:nvSpPr>
-          <p:cNvPr id="21" name="Oval 20"/>
+          <p:cNvPr id="19" name="Oval 18"/>
           <p:cNvSpPr/>
           <p:nvPr/>
         </p:nvSpPr>
@@ -22835,7 +22757,7 @@
       </p:sp>
       <p:sp>
         <p:nvSpPr>
-          <p:cNvPr id="22" name="TextBox 21"/>
+          <p:cNvPr id="20" name="TextBox 19"/>
           <p:cNvSpPr txBox="1"/>
           <p:nvPr/>
         </p:nvSpPr>
@@ -22870,7 +22792,7 @@
       </p:sp>
       <p:sp>
         <p:nvSpPr>
-          <p:cNvPr id="23" name="Oval 22"/>
+          <p:cNvPr id="21" name="Oval 20"/>
           <p:cNvSpPr/>
           <p:nvPr/>
         </p:nvSpPr>
@@ -22914,7 +22836,7 @@
       </p:sp>
       <p:sp>
         <p:nvSpPr>
-          <p:cNvPr id="24" name="TextBox 23"/>
+          <p:cNvPr id="22" name="TextBox 21"/>
           <p:cNvSpPr txBox="1"/>
           <p:nvPr/>
         </p:nvSpPr>
@@ -22949,7 +22871,7 @@
       </p:sp>
       <p:sp>
         <p:nvSpPr>
-          <p:cNvPr id="25" name="TextBox 24"/>
+          <p:cNvPr id="23" name="TextBox 22"/>
           <p:cNvSpPr txBox="1"/>
           <p:nvPr/>
         </p:nvSpPr>
@@ -25753,7 +25675,7 @@
       </p:sp>
       <p:pic>
         <p:nvPicPr>
-          <p:cNvPr id="9" name="mermaid diagram" descr="75da118c6c09b653.png"/>
+          <p:cNvPr id="9" name="mermaid diagram" descr="61638b4d14f8196c.png"/>
           <p:cNvPicPr>
             <a:picLocks noChangeAspect="1"/>
           </p:cNvPicPr>
@@ -27572,7 +27494,7 @@
       </p:sp>
       <p:pic>
         <p:nvPicPr>
-          <p:cNvPr id="9" name="mermaid diagram" descr="6183dc27bdd6055b.png"/>
+          <p:cNvPr id="9" name="mermaid diagram" descr="12b381e01980df02.png"/>
           <p:cNvPicPr>
             <a:picLocks noChangeAspect="1"/>
           </p:cNvPicPr>

</xml_diff>